<commit_message>
Presentacion y Guion terminado
</commit_message>
<xml_diff>
--- a/Asignaturas 2/Proyecto Intermodular/Presentacion/version Final 3/Defensa_TFG_LudiGest_Rubrica.pptx
+++ b/Asignaturas 2/Proyecto Intermodular/Presentacion/version Final 3/Defensa_TFG_LudiGest_Rubrica.pptx
@@ -15,9 +15,9 @@
     <p:sldId id="260" r:id="rId6"/>
     <p:sldId id="261" r:id="rId7"/>
     <p:sldId id="262" r:id="rId8"/>
-    <p:sldId id="264" r:id="rId9"/>
-    <p:sldId id="265" r:id="rId10"/>
-    <p:sldId id="263" r:id="rId11"/>
+    <p:sldId id="263" r:id="rId9"/>
+    <p:sldId id="264" r:id="rId10"/>
+    <p:sldId id="265" r:id="rId11"/>
     <p:sldId id="266" r:id="rId12"/>
   </p:sldIdLst>
   <p:sldSz cx="12192000" cy="6858000"/>
@@ -850,7 +850,7 @@
   <p:cSld>
     <p:spTree>
       <p:nvGrpSpPr>
-        <p:cNvPr id="1" name="Shape 243"/>
+        <p:cNvPr id="1" name="Shape 279"/>
         <p:cNvGrpSpPr/>
         <p:nvPr/>
       </p:nvGrpSpPr>
@@ -864,7 +864,7 @@
       </p:grpSpPr>
       <p:sp>
         <p:nvSpPr>
-          <p:cNvPr id="244" name="Google Shape;244;p8:notes"/>
+          <p:cNvPr id="280" name="Google Shape;280;p10:notes"/>
           <p:cNvSpPr txBox="1">
             <a:spLocks noGrp="1"/>
           </p:cNvSpPr>
@@ -902,7 +902,7 @@
       </p:sp>
       <p:sp>
         <p:nvSpPr>
-          <p:cNvPr id="245" name="Google Shape;245;p8:notes"/>
+          <p:cNvPr id="281" name="Google Shape;281;p10:notes"/>
           <p:cNvSpPr>
             <a:spLocks noGrp="1" noRot="1" noChangeAspect="1"/>
           </p:cNvSpPr>
@@ -1682,6 +1682,110 @@
   <p:cSld>
     <p:spTree>
       <p:nvGrpSpPr>
+        <p:cNvPr id="1" name="Shape 243"/>
+        <p:cNvGrpSpPr/>
+        <p:nvPr/>
+      </p:nvGrpSpPr>
+      <p:grpSpPr>
+        <a:xfrm>
+          <a:off x="0" y="0"/>
+          <a:ext cx="0" cy="0"/>
+          <a:chOff x="0" y="0"/>
+          <a:chExt cx="0" cy="0"/>
+        </a:xfrm>
+      </p:grpSpPr>
+      <p:sp>
+        <p:nvSpPr>
+          <p:cNvPr id="244" name="Google Shape;244;p8:notes"/>
+          <p:cNvSpPr txBox="1">
+            <a:spLocks noGrp="1"/>
+          </p:cNvSpPr>
+          <p:nvPr>
+            <p:ph type="body" idx="1"/>
+          </p:nvPr>
+        </p:nvSpPr>
+        <p:spPr>
+          <a:xfrm>
+            <a:off x="685800" y="4343400"/>
+            <a:ext cx="5486400" cy="4114800"/>
+          </a:xfrm>
+          <a:prstGeom prst="rect">
+            <a:avLst/>
+          </a:prstGeom>
+        </p:spPr>
+        <p:txBody>
+          <a:bodyPr spcFirstLastPara="1" wrap="square" lIns="91425" tIns="91425" rIns="91425" bIns="91425" anchor="t" anchorCtr="0">
+            <a:noAutofit/>
+          </a:bodyPr>
+          <a:lstStyle/>
+          <a:p>
+            <a:pPr marL="0" lvl="0" indent="0" algn="l" rtl="0">
+              <a:spcBef>
+                <a:spcPts val="0"/>
+              </a:spcBef>
+              <a:spcAft>
+                <a:spcPts val="0"/>
+              </a:spcAft>
+              <a:buNone/>
+            </a:pPr>
+            <a:endParaRPr/>
+          </a:p>
+        </p:txBody>
+      </p:sp>
+      <p:sp>
+        <p:nvSpPr>
+          <p:cNvPr id="245" name="Google Shape;245;p8:notes"/>
+          <p:cNvSpPr>
+            <a:spLocks noGrp="1" noRot="1" noChangeAspect="1"/>
+          </p:cNvSpPr>
+          <p:nvPr>
+            <p:ph type="sldImg" idx="2"/>
+          </p:nvPr>
+        </p:nvSpPr>
+        <p:spPr>
+          <a:xfrm>
+            <a:off x="381000" y="685800"/>
+            <a:ext cx="6096000" cy="3429000"/>
+          </a:xfrm>
+          <a:custGeom>
+            <a:avLst/>
+            <a:gdLst/>
+            <a:ahLst/>
+            <a:cxnLst/>
+            <a:rect l="l" t="t" r="r" b="b"/>
+            <a:pathLst>
+              <a:path w="120000" h="120000" extrusionOk="0">
+                <a:moveTo>
+                  <a:pt x="0" y="0"/>
+                </a:moveTo>
+                <a:lnTo>
+                  <a:pt x="120000" y="0"/>
+                </a:lnTo>
+                <a:lnTo>
+                  <a:pt x="120000" y="120000"/>
+                </a:lnTo>
+                <a:lnTo>
+                  <a:pt x="0" y="120000"/>
+                </a:lnTo>
+                <a:close/>
+              </a:path>
+            </a:pathLst>
+          </a:custGeom>
+        </p:spPr>
+      </p:sp>
+    </p:spTree>
+  </p:cSld>
+  <p:clrMapOvr>
+    <a:masterClrMapping/>
+  </p:clrMapOvr>
+</p:notes>
+</file>
+
+<file path=ppt/notesSlides/notesSlide9.xml><?xml version="1.0" encoding="utf-8"?>
+<p:notes xmlns:a="http://schemas.openxmlformats.org/drawingml/2006/main" xmlns:r="http://schemas.openxmlformats.org/officeDocument/2006/relationships" xmlns:p="http://schemas.openxmlformats.org/presentationml/2006/main" showMasterSp="0" showMasterPhAnim="0">
+  <p:cSld>
+    <p:spTree>
+      <p:nvGrpSpPr>
         <p:cNvPr id="1" name="Shape 260"/>
         <p:cNvGrpSpPr/>
         <p:nvPr/>
@@ -1735,110 +1839,6 @@
       <p:sp>
         <p:nvSpPr>
           <p:cNvPr id="262" name="Google Shape;262;p9:notes"/>
-          <p:cNvSpPr>
-            <a:spLocks noGrp="1" noRot="1" noChangeAspect="1"/>
-          </p:cNvSpPr>
-          <p:nvPr>
-            <p:ph type="sldImg" idx="2"/>
-          </p:nvPr>
-        </p:nvSpPr>
-        <p:spPr>
-          <a:xfrm>
-            <a:off x="381000" y="685800"/>
-            <a:ext cx="6096000" cy="3429000"/>
-          </a:xfrm>
-          <a:custGeom>
-            <a:avLst/>
-            <a:gdLst/>
-            <a:ahLst/>
-            <a:cxnLst/>
-            <a:rect l="l" t="t" r="r" b="b"/>
-            <a:pathLst>
-              <a:path w="120000" h="120000" extrusionOk="0">
-                <a:moveTo>
-                  <a:pt x="0" y="0"/>
-                </a:moveTo>
-                <a:lnTo>
-                  <a:pt x="120000" y="0"/>
-                </a:lnTo>
-                <a:lnTo>
-                  <a:pt x="120000" y="120000"/>
-                </a:lnTo>
-                <a:lnTo>
-                  <a:pt x="0" y="120000"/>
-                </a:lnTo>
-                <a:close/>
-              </a:path>
-            </a:pathLst>
-          </a:custGeom>
-        </p:spPr>
-      </p:sp>
-    </p:spTree>
-  </p:cSld>
-  <p:clrMapOvr>
-    <a:masterClrMapping/>
-  </p:clrMapOvr>
-</p:notes>
-</file>
-
-<file path=ppt/notesSlides/notesSlide9.xml><?xml version="1.0" encoding="utf-8"?>
-<p:notes xmlns:a="http://schemas.openxmlformats.org/drawingml/2006/main" xmlns:r="http://schemas.openxmlformats.org/officeDocument/2006/relationships" xmlns:p="http://schemas.openxmlformats.org/presentationml/2006/main" showMasterSp="0" showMasterPhAnim="0">
-  <p:cSld>
-    <p:spTree>
-      <p:nvGrpSpPr>
-        <p:cNvPr id="1" name="Shape 279"/>
-        <p:cNvGrpSpPr/>
-        <p:nvPr/>
-      </p:nvGrpSpPr>
-      <p:grpSpPr>
-        <a:xfrm>
-          <a:off x="0" y="0"/>
-          <a:ext cx="0" cy="0"/>
-          <a:chOff x="0" y="0"/>
-          <a:chExt cx="0" cy="0"/>
-        </a:xfrm>
-      </p:grpSpPr>
-      <p:sp>
-        <p:nvSpPr>
-          <p:cNvPr id="280" name="Google Shape;280;p10:notes"/>
-          <p:cNvSpPr txBox="1">
-            <a:spLocks noGrp="1"/>
-          </p:cNvSpPr>
-          <p:nvPr>
-            <p:ph type="body" idx="1"/>
-          </p:nvPr>
-        </p:nvSpPr>
-        <p:spPr>
-          <a:xfrm>
-            <a:off x="685800" y="4343400"/>
-            <a:ext cx="5486400" cy="4114800"/>
-          </a:xfrm>
-          <a:prstGeom prst="rect">
-            <a:avLst/>
-          </a:prstGeom>
-        </p:spPr>
-        <p:txBody>
-          <a:bodyPr spcFirstLastPara="1" wrap="square" lIns="91425" tIns="91425" rIns="91425" bIns="91425" anchor="t" anchorCtr="0">
-            <a:noAutofit/>
-          </a:bodyPr>
-          <a:lstStyle/>
-          <a:p>
-            <a:pPr marL="0" lvl="0" indent="0" algn="l" rtl="0">
-              <a:spcBef>
-                <a:spcPts val="0"/>
-              </a:spcBef>
-              <a:spcAft>
-                <a:spcPts val="0"/>
-              </a:spcAft>
-              <a:buNone/>
-            </a:pPr>
-            <a:endParaRPr/>
-          </a:p>
-        </p:txBody>
-      </p:sp>
-      <p:sp>
-        <p:nvSpPr>
-          <p:cNvPr id="281" name="Google Shape;281;p10:notes"/>
           <p:cNvSpPr>
             <a:spLocks noGrp="1" noRot="1" noChangeAspect="1"/>
           </p:cNvSpPr>
@@ -12069,14 +12069,14 @@
     <p:bg>
       <p:bgPr>
         <a:solidFill>
-          <a:srgbClr val="05080F"/>
+          <a:srgbClr val="0B1120"/>
         </a:solidFill>
         <a:effectLst/>
       </p:bgPr>
     </p:bg>
     <p:spTree>
       <p:nvGrpSpPr>
-        <p:cNvPr id="1" name="Shape 246"/>
+        <p:cNvPr id="1" name="Shape 282"/>
         <p:cNvGrpSpPr/>
         <p:nvPr/>
       </p:nvGrpSpPr>
@@ -12090,7 +12090,7 @@
       </p:grpSpPr>
       <p:pic>
         <p:nvPicPr>
-          <p:cNvPr id="247" name="Google Shape;247;p20" descr="image.png"/>
+          <p:cNvPr id="283" name="Google Shape;283;p22" descr="image.png"/>
           <p:cNvPicPr preferRelativeResize="0"/>
           <p:nvPr/>
         </p:nvPicPr>
@@ -12117,7 +12117,7 @@
       </p:pic>
       <p:pic>
         <p:nvPicPr>
-          <p:cNvPr id="249" name="Google Shape;249;p20" descr="image.png"/>
+          <p:cNvPr id="285" name="Google Shape;285;p22" descr="image.png"/>
           <p:cNvPicPr preferRelativeResize="0"/>
           <p:nvPr/>
         </p:nvPicPr>
@@ -12130,6 +12130,33 @@
         </p:blipFill>
         <p:spPr>
           <a:xfrm>
+            <a:off x="6334125" y="2426940"/>
+            <a:ext cx="5276850" cy="2785020"/>
+          </a:xfrm>
+          <a:prstGeom prst="rect">
+            <a:avLst/>
+          </a:prstGeom>
+          <a:noFill/>
+          <a:ln>
+            <a:noFill/>
+          </a:ln>
+        </p:spPr>
+      </p:pic>
+      <p:pic>
+        <p:nvPicPr>
+          <p:cNvPr id="286" name="Google Shape;286;p22" descr="image.png"/>
+          <p:cNvPicPr preferRelativeResize="0"/>
+          <p:nvPr/>
+        </p:nvPicPr>
+        <p:blipFill rotWithShape="1">
+          <a:blip r:embed="rId5">
+            <a:alphaModFix/>
+          </a:blip>
+          <a:srcRect/>
+          <a:stretch/>
+        </p:blipFill>
+        <p:spPr>
+          <a:xfrm>
             <a:off x="581025" y="6248400"/>
             <a:ext cx="11029950" cy="314325"/>
           </a:xfrm>
@@ -12144,7 +12171,7 @@
       </p:pic>
       <p:sp>
         <p:nvSpPr>
-          <p:cNvPr id="250" name="Google Shape;250;p20"/>
+          <p:cNvPr id="287" name="Google Shape;287;p22"/>
           <p:cNvSpPr txBox="1"/>
           <p:nvPr/>
         </p:nvSpPr>
@@ -12167,7 +12194,7 @@
           </a:bodyPr>
           <a:lstStyle/>
           <a:p>
-            <a:pPr marL="0" marR="0" lvl="0" indent="0" algn="ctr" rtl="0">
+            <a:pPr marL="0" marR="0" lvl="0" indent="0" algn="l" rtl="0">
               <a:spcBef>
                 <a:spcPts val="0"/>
               </a:spcBef>
@@ -12194,14 +12221,323 @@
       </p:sp>
       <p:sp>
         <p:nvSpPr>
-          <p:cNvPr id="251" name="Google Shape;251;p20"/>
+          <p:cNvPr id="288" name="Google Shape;288;p22"/>
           <p:cNvSpPr txBox="1"/>
           <p:nvPr/>
         </p:nvSpPr>
         <p:spPr>
           <a:xfrm>
-            <a:off x="9372600" y="6400800"/>
-            <a:ext cx="2238375" cy="161925"/>
+            <a:off x="10239375" y="6400800"/>
+            <a:ext cx="1371600" cy="161925"/>
+          </a:xfrm>
+          <a:prstGeom prst="rect">
+            <a:avLst/>
+          </a:prstGeom>
+          <a:noFill/>
+          <a:ln>
+            <a:noFill/>
+          </a:ln>
+        </p:spPr>
+        <p:txBody>
+          <a:bodyPr spcFirstLastPara="1" wrap="square" lIns="0" tIns="0" rIns="0" bIns="0" anchor="t" anchorCtr="0">
+            <a:spAutoFit/>
+          </a:bodyPr>
+          <a:lstStyle/>
+          <a:p>
+            <a:pPr marL="0" marR="0" lvl="0" indent="0" algn="l" rtl="0">
+              <a:spcBef>
+                <a:spcPts val="0"/>
+              </a:spcBef>
+              <a:spcAft>
+                <a:spcPts val="0"/>
+              </a:spcAft>
+              <a:buNone/>
+            </a:pPr>
+            <a:r>
+              <a:rPr lang="en-US" sz="1050" b="0" i="0" u="none" strike="noStrike" cap="none">
+                <a:solidFill>
+                  <a:srgbClr val="94A3B8"/>
+                </a:solidFill>
+                <a:latin typeface="Inter"/>
+                <a:ea typeface="Inter"/>
+                <a:cs typeface="Inter"/>
+                <a:sym typeface="Inter"/>
+              </a:rPr>
+              <a:t>Fin de la Presentación</a:t>
+            </a:r>
+            <a:endParaRPr/>
+          </a:p>
+        </p:txBody>
+      </p:sp>
+      <p:pic>
+        <p:nvPicPr>
+          <p:cNvPr id="289" name="Google Shape;289;p22" descr="image.png"/>
+          <p:cNvPicPr preferRelativeResize="0"/>
+          <p:nvPr/>
+        </p:nvPicPr>
+        <p:blipFill rotWithShape="1">
+          <a:blip r:embed="rId6">
+            <a:alphaModFix/>
+          </a:blip>
+          <a:srcRect/>
+          <a:stretch/>
+        </p:blipFill>
+        <p:spPr>
+          <a:xfrm>
+            <a:off x="8615362" y="2817465"/>
+            <a:ext cx="714375" cy="571500"/>
+          </a:xfrm>
+          <a:prstGeom prst="rect">
+            <a:avLst/>
+          </a:prstGeom>
+          <a:noFill/>
+          <a:ln>
+            <a:noFill/>
+          </a:ln>
+        </p:spPr>
+      </p:pic>
+      <p:pic>
+        <p:nvPicPr>
+          <p:cNvPr id="290" name="Google Shape;290;p22" descr="image.png"/>
+          <p:cNvPicPr preferRelativeResize="0"/>
+          <p:nvPr/>
+        </p:nvPicPr>
+        <p:blipFill rotWithShape="1">
+          <a:blip r:embed="rId7">
+            <a:alphaModFix/>
+          </a:blip>
+          <a:srcRect/>
+          <a:stretch/>
+        </p:blipFill>
+        <p:spPr>
+          <a:xfrm>
+            <a:off x="581025" y="3425279"/>
+            <a:ext cx="171450" cy="200025"/>
+          </a:xfrm>
+          <a:prstGeom prst="rect">
+            <a:avLst/>
+          </a:prstGeom>
+          <a:noFill/>
+          <a:ln>
+            <a:noFill/>
+          </a:ln>
+        </p:spPr>
+      </p:pic>
+      <p:pic>
+        <p:nvPicPr>
+          <p:cNvPr id="291" name="Google Shape;291;p22" descr="image.png"/>
+          <p:cNvPicPr preferRelativeResize="0"/>
+          <p:nvPr/>
+        </p:nvPicPr>
+        <p:blipFill rotWithShape="1">
+          <a:blip r:embed="rId7">
+            <a:alphaModFix/>
+          </a:blip>
+          <a:srcRect/>
+          <a:stretch/>
+        </p:blipFill>
+        <p:spPr>
+          <a:xfrm>
+            <a:off x="581025" y="4147095"/>
+            <a:ext cx="171450" cy="200025"/>
+          </a:xfrm>
+          <a:prstGeom prst="rect">
+            <a:avLst/>
+          </a:prstGeom>
+          <a:noFill/>
+          <a:ln>
+            <a:noFill/>
+          </a:ln>
+        </p:spPr>
+      </p:pic>
+      <p:pic>
+        <p:nvPicPr>
+          <p:cNvPr id="292" name="Google Shape;292;p22" descr="image.png"/>
+          <p:cNvPicPr preferRelativeResize="0"/>
+          <p:nvPr/>
+        </p:nvPicPr>
+        <p:blipFill rotWithShape="1">
+          <a:blip r:embed="rId7">
+            <a:alphaModFix/>
+          </a:blip>
+          <a:srcRect/>
+          <a:stretch/>
+        </p:blipFill>
+        <p:spPr>
+          <a:xfrm>
+            <a:off x="581025" y="4868912"/>
+            <a:ext cx="171450" cy="200025"/>
+          </a:xfrm>
+          <a:prstGeom prst="rect">
+            <a:avLst/>
+          </a:prstGeom>
+          <a:noFill/>
+          <a:ln>
+            <a:noFill/>
+          </a:ln>
+        </p:spPr>
+      </p:pic>
+      <p:sp>
+        <p:nvSpPr>
+          <p:cNvPr id="293" name="Google Shape;293;p22"/>
+          <p:cNvSpPr txBox="1"/>
+          <p:nvPr/>
+        </p:nvSpPr>
+        <p:spPr>
+          <a:xfrm>
+            <a:off x="771525" y="485775"/>
+            <a:ext cx="11381422" cy="542925"/>
+          </a:xfrm>
+          <a:prstGeom prst="rect">
+            <a:avLst/>
+          </a:prstGeom>
+          <a:noFill/>
+          <a:ln>
+            <a:noFill/>
+          </a:ln>
+        </p:spPr>
+        <p:txBody>
+          <a:bodyPr spcFirstLastPara="1" wrap="square" lIns="0" tIns="0" rIns="0" bIns="0" anchor="t" anchorCtr="0">
+            <a:spAutoFit/>
+          </a:bodyPr>
+          <a:lstStyle/>
+          <a:p>
+            <a:pPr marL="0" marR="0" lvl="0" indent="0" algn="l" rtl="0">
+              <a:spcBef>
+                <a:spcPts val="0"/>
+              </a:spcBef>
+              <a:spcAft>
+                <a:spcPts val="0"/>
+              </a:spcAft>
+              <a:buNone/>
+            </a:pPr>
+            <a:r>
+              <a:rPr lang="en-US" sz="2850" b="1" i="0" u="none" strike="noStrike" cap="none">
+                <a:solidFill>
+                  <a:srgbClr val="F8FAFC"/>
+                </a:solidFill>
+                <a:latin typeface="Poppins"/>
+                <a:ea typeface="Poppins"/>
+                <a:cs typeface="Poppins"/>
+                <a:sym typeface="Poppins"/>
+              </a:rPr>
+              <a:t>9. Conclusiones Personales</a:t>
+            </a:r>
+            <a:endParaRPr/>
+          </a:p>
+        </p:txBody>
+      </p:sp>
+      <p:sp>
+        <p:nvSpPr>
+          <p:cNvPr id="294" name="Google Shape;294;p22"/>
+          <p:cNvSpPr/>
+          <p:nvPr/>
+        </p:nvSpPr>
+        <p:spPr>
+          <a:xfrm>
+            <a:off x="581025" y="485775"/>
+            <a:ext cx="57150" cy="542925"/>
+          </a:xfrm>
+          <a:prstGeom prst="rect">
+            <a:avLst/>
+          </a:prstGeom>
+          <a:solidFill>
+            <a:srgbClr val="0EA5E9"/>
+          </a:solidFill>
+          <a:ln>
+            <a:noFill/>
+          </a:ln>
+        </p:spPr>
+        <p:txBody>
+          <a:bodyPr spcFirstLastPara="1" wrap="square" lIns="91425" tIns="45700" rIns="91425" bIns="45700" anchor="ctr" anchorCtr="0">
+            <a:noAutofit/>
+          </a:bodyPr>
+          <a:lstStyle/>
+          <a:p>
+            <a:pPr marL="0" marR="0" lvl="0" indent="0" algn="ctr" rtl="0">
+              <a:spcBef>
+                <a:spcPts val="0"/>
+              </a:spcBef>
+              <a:spcAft>
+                <a:spcPts val="0"/>
+              </a:spcAft>
+              <a:buNone/>
+            </a:pPr>
+            <a:endParaRPr sz="1800" b="0" i="0" u="none" strike="noStrike" cap="none">
+              <a:solidFill>
+                <a:schemeClr val="dk1"/>
+              </a:solidFill>
+              <a:latin typeface="Calibri"/>
+              <a:ea typeface="Calibri"/>
+              <a:cs typeface="Calibri"/>
+              <a:sym typeface="Calibri"/>
+            </a:endParaRPr>
+          </a:p>
+        </p:txBody>
+      </p:sp>
+      <p:sp>
+        <p:nvSpPr>
+          <p:cNvPr id="295" name="Google Shape;295;p22"/>
+          <p:cNvSpPr txBox="1"/>
+          <p:nvPr/>
+        </p:nvSpPr>
+        <p:spPr>
+          <a:xfrm>
+            <a:off x="581025" y="2091183"/>
+            <a:ext cx="5276850" cy="1005482"/>
+          </a:xfrm>
+          <a:prstGeom prst="rect">
+            <a:avLst/>
+          </a:prstGeom>
+          <a:noFill/>
+          <a:ln>
+            <a:noFill/>
+          </a:ln>
+        </p:spPr>
+        <p:txBody>
+          <a:bodyPr spcFirstLastPara="1" wrap="square" lIns="0" tIns="0" rIns="0" bIns="0" anchor="t" anchorCtr="0">
+            <a:spAutoFit/>
+          </a:bodyPr>
+          <a:lstStyle/>
+          <a:p>
+            <a:pPr marL="0" marR="0" lvl="0" indent="0" algn="l" rtl="0">
+              <a:lnSpc>
+                <a:spcPct val="160000"/>
+              </a:lnSpc>
+              <a:spcBef>
+                <a:spcPts val="0"/>
+              </a:spcBef>
+              <a:spcAft>
+                <a:spcPts val="0"/>
+              </a:spcAft>
+              <a:buNone/>
+            </a:pPr>
+            <a:r>
+              <a:rPr lang="en-US" sz="1650" b="0" i="0" u="none" strike="noStrike" cap="none">
+                <a:solidFill>
+                  <a:srgbClr val="94A3B8"/>
+                </a:solidFill>
+                <a:latin typeface="Inter"/>
+                <a:ea typeface="Inter"/>
+                <a:cs typeface="Inter"/>
+                <a:sym typeface="Inter"/>
+              </a:rPr>
+              <a:t>Este Trabajo de Fin de Grado me ha permitido enfrentarme al ciclo de vida completo de un software profesional:</a:t>
+            </a:r>
+            <a:endParaRPr/>
+          </a:p>
+        </p:txBody>
+      </p:sp>
+      <p:sp>
+        <p:nvSpPr>
+          <p:cNvPr id="296" name="Google Shape;296;p22"/>
+          <p:cNvSpPr txBox="1"/>
+          <p:nvPr/>
+        </p:nvSpPr>
+        <p:spPr>
+          <a:xfrm>
+            <a:off x="6612255" y="3579465"/>
+            <a:ext cx="4720590" cy="276225"/>
           </a:xfrm>
           <a:prstGeom prst="rect">
             <a:avLst/>
@@ -12227,147 +12563,16 @@
               <a:buNone/>
             </a:pPr>
             <a:r>
-              <a:rPr lang="en-US" sz="1050" b="0" i="0" u="none" strike="noStrike" cap="none">
-                <a:solidFill>
-                  <a:srgbClr val="94A3B8"/>
-                </a:solidFill>
-                <a:latin typeface="Inter"/>
-                <a:ea typeface="Inter"/>
-                <a:cs typeface="Inter"/>
-                <a:sym typeface="Inter"/>
-              </a:rPr>
-              <a:t>Demostración Práctica (Máx. 2 min)</a:t>
-            </a:r>
-            <a:endParaRPr/>
-          </a:p>
-        </p:txBody>
-      </p:sp>
-      <p:pic>
-        <p:nvPicPr>
-          <p:cNvPr id="252" name="Google Shape;252;p20" descr="image.png"/>
-          <p:cNvPicPr preferRelativeResize="0"/>
-          <p:nvPr/>
-        </p:nvPicPr>
-        <p:blipFill rotWithShape="1">
-          <a:blip r:embed="rId5">
-            <a:alphaModFix/>
-          </a:blip>
-          <a:srcRect/>
-          <a:stretch/>
-        </p:blipFill>
-        <p:spPr>
-          <a:xfrm>
-            <a:off x="3633787" y="3796754"/>
-            <a:ext cx="142875" cy="200025"/>
-          </a:xfrm>
-          <a:prstGeom prst="rect">
-            <a:avLst/>
-          </a:prstGeom>
-          <a:noFill/>
-          <a:ln>
-            <a:noFill/>
-          </a:ln>
-        </p:spPr>
-      </p:pic>
-      <p:pic>
-        <p:nvPicPr>
-          <p:cNvPr id="253" name="Google Shape;253;p20" descr="image.png"/>
-          <p:cNvPicPr preferRelativeResize="0"/>
-          <p:nvPr/>
-        </p:nvPicPr>
-        <p:blipFill rotWithShape="1">
-          <a:blip r:embed="rId5">
-            <a:alphaModFix/>
-          </a:blip>
-          <a:srcRect/>
-          <a:stretch/>
-        </p:blipFill>
-        <p:spPr>
-          <a:xfrm>
-            <a:off x="3633787" y="4229100"/>
-            <a:ext cx="142875" cy="200025"/>
-          </a:xfrm>
-          <a:prstGeom prst="rect">
-            <a:avLst/>
-          </a:prstGeom>
-          <a:noFill/>
-          <a:ln>
-            <a:noFill/>
-          </a:ln>
-        </p:spPr>
-      </p:pic>
-      <p:pic>
-        <p:nvPicPr>
-          <p:cNvPr id="254" name="Google Shape;254;p20" descr="image.png"/>
-          <p:cNvPicPr preferRelativeResize="0"/>
-          <p:nvPr/>
-        </p:nvPicPr>
-        <p:blipFill rotWithShape="1">
-          <a:blip r:embed="rId5">
-            <a:alphaModFix/>
-          </a:blip>
-          <a:srcRect/>
-          <a:stretch/>
-        </p:blipFill>
-        <p:spPr>
-          <a:xfrm>
-            <a:off x="3633787" y="4661445"/>
-            <a:ext cx="142875" cy="200025"/>
-          </a:xfrm>
-          <a:prstGeom prst="rect">
-            <a:avLst/>
-          </a:prstGeom>
-          <a:noFill/>
-          <a:ln>
-            <a:noFill/>
-          </a:ln>
-        </p:spPr>
-      </p:pic>
-      <p:sp>
-        <p:nvSpPr>
-          <p:cNvPr id="255" name="Google Shape;255;p20"/>
-          <p:cNvSpPr txBox="1"/>
-          <p:nvPr/>
-        </p:nvSpPr>
-        <p:spPr>
-          <a:xfrm>
-            <a:off x="1365408" y="1807071"/>
-            <a:ext cx="9461182" cy="1009650"/>
-          </a:xfrm>
-          <a:prstGeom prst="rect">
-            <a:avLst/>
-          </a:prstGeom>
-          <a:noFill/>
-          <a:ln>
-            <a:noFill/>
-          </a:ln>
-        </p:spPr>
-        <p:txBody>
-          <a:bodyPr spcFirstLastPara="1" wrap="square" lIns="0" tIns="0" rIns="0" bIns="0" anchor="t" anchorCtr="0">
-            <a:spAutoFit/>
-          </a:bodyPr>
-          <a:lstStyle/>
-          <a:p>
-            <a:pPr marL="0" marR="0" lvl="0" indent="0" algn="ctr" rtl="0">
-              <a:spcBef>
-                <a:spcPts val="0"/>
-              </a:spcBef>
-              <a:spcAft>
-                <a:spcPts val="0"/>
-              </a:spcAft>
-              <a:buNone/>
-            </a:pPr>
-            <a:r>
-              <a:rPr lang="en-US" sz="5250" b="1" i="0" u="none" strike="noStrike" cap="none">
-                <a:solidFill>
-                  <a:srgbClr val="0EA5E9"/>
+              <a:rPr lang="en-US" sz="1404" b="1" i="0" u="none" strike="noStrike" cap="none">
+                <a:solidFill>
+                  <a:srgbClr val="F8FAFC"/>
                 </a:solidFill>
                 <a:latin typeface="Poppins"/>
                 <a:ea typeface="Poppins"/>
                 <a:cs typeface="Poppins"/>
                 <a:sym typeface="Poppins"/>
               </a:rPr>
-              <a:t>6. DEMOSTRACIÓN EN VIVO</a:t>
+              <a:t>Objetivo Cumplido</a:t>
             </a:r>
             <a:endParaRPr/>
           </a:p>
@@ -12375,14 +12580,14 @@
       </p:sp>
       <p:sp>
         <p:nvSpPr>
-          <p:cNvPr id="256" name="Google Shape;256;p20"/>
+          <p:cNvPr id="297" name="Google Shape;297;p22"/>
           <p:cNvSpPr txBox="1"/>
           <p:nvPr/>
         </p:nvSpPr>
         <p:spPr>
           <a:xfrm>
-            <a:off x="4552950" y="3007221"/>
-            <a:ext cx="3086100" cy="365670"/>
+            <a:off x="6724650" y="3998565"/>
+            <a:ext cx="4495800" cy="822870"/>
           </a:xfrm>
           <a:prstGeom prst="rect">
             <a:avLst/>
@@ -12400,7 +12605,7 @@
           <a:p>
             <a:pPr marL="0" marR="0" lvl="0" indent="0" algn="ctr" rtl="0">
               <a:lnSpc>
-                <a:spcPct val="159944"/>
+                <a:spcPct val="160000"/>
               </a:lnSpc>
               <a:spcBef>
                 <a:spcPts val="0"/>
@@ -12411,16 +12616,16 @@
               <a:buNone/>
             </a:pPr>
             <a:r>
-              <a:rPr lang="en-US" sz="1800" b="0" i="0" u="none" strike="noStrike" cap="none">
-                <a:solidFill>
-                  <a:srgbClr val="F8FAFC"/>
+              <a:rPr lang="en-US" sz="1350" b="0" i="0" u="none" strike="noStrike" cap="none">
+                <a:solidFill>
+                  <a:srgbClr val="94A3B8"/>
                 </a:solidFill>
                 <a:latin typeface="Inter"/>
                 <a:ea typeface="Inter"/>
                 <a:cs typeface="Inter"/>
                 <a:sym typeface="Inter"/>
               </a:rPr>
-              <a:t>Flujo Completo de Ejecución</a:t>
+              <a:t>LudiGest no es solo un proyecto académico; es una solución real y funcional lista para ser desplegada en producción.</a:t>
             </a:r>
             <a:endParaRPr/>
           </a:p>
@@ -12428,14 +12633,14 @@
       </p:sp>
       <p:sp>
         <p:nvSpPr>
-          <p:cNvPr id="257" name="Google Shape;257;p20"/>
+          <p:cNvPr id="298" name="Google Shape;298;p22"/>
           <p:cNvSpPr txBox="1"/>
           <p:nvPr/>
         </p:nvSpPr>
         <p:spPr>
           <a:xfrm>
-            <a:off x="4014787" y="3753891"/>
-            <a:ext cx="4543425" cy="289470"/>
+            <a:off x="962025" y="3382416"/>
+            <a:ext cx="4895850" cy="578941"/>
           </a:xfrm>
           <a:prstGeom prst="rect">
             <a:avLst/>
@@ -12464,7 +12669,7 @@
               <a:buNone/>
             </a:pPr>
             <a:r>
-              <a:rPr lang="en-US" sz="1425" b="0" i="0" u="none" strike="noStrike" cap="none" dirty="0">
+              <a:rPr lang="en-US" sz="1425" b="0" i="0" u="none" strike="noStrike" cap="none">
                 <a:solidFill>
                   <a:srgbClr val="94A3B8"/>
                 </a:solidFill>
@@ -12473,10 +12678,22 @@
                 <a:cs typeface="Inter"/>
                 <a:sym typeface="Inter"/>
               </a:rPr>
-              <a:t>1. </a:t>
+              <a:t>Comprensión profunda de la </a:t>
             </a:r>
             <a:r>
-              <a:rPr lang="en-US" sz="1425" b="0" i="0" u="none" strike="noStrike" cap="none" dirty="0" err="1">
+              <a:rPr lang="en-US" sz="1425" b="0" i="0" u="none" strike="noStrike" cap="none">
+                <a:solidFill>
+                  <a:srgbClr val="F8FAFC"/>
+                </a:solidFill>
+                <a:latin typeface="Inter SemiBold"/>
+                <a:ea typeface="Inter SemiBold"/>
+                <a:cs typeface="Inter SemiBold"/>
+                <a:sym typeface="Inter SemiBold"/>
+              </a:rPr>
+              <a:t>arquitectura y patrones de diseño</a:t>
+            </a:r>
+            <a:r>
+              <a:rPr lang="en-US" sz="1425" b="0" i="0" u="none" strike="noStrike" cap="none">
                 <a:solidFill>
                   <a:srgbClr val="94A3B8"/>
                 </a:solidFill>
@@ -12485,106 +12702,22 @@
                 <a:cs typeface="Inter"/>
                 <a:sym typeface="Inter"/>
               </a:rPr>
-              <a:t>Importación</a:t>
+              <a:t> (MVC, REST, DTOs).</a:t>
             </a:r>
-            <a:r>
-              <a:rPr lang="en-US" sz="1425" b="0" i="0" u="none" strike="noStrike" cap="none" dirty="0">
-                <a:solidFill>
-                  <a:srgbClr val="94A3B8"/>
-                </a:solidFill>
-                <a:latin typeface="Inter"/>
-                <a:ea typeface="Inter"/>
-                <a:cs typeface="Inter"/>
-                <a:sym typeface="Inter"/>
-              </a:rPr>
-              <a:t> </a:t>
-            </a:r>
-            <a:r>
-              <a:rPr lang="en-US" sz="1425" b="0" i="0" u="none" strike="noStrike" cap="none" dirty="0" err="1">
-                <a:solidFill>
-                  <a:srgbClr val="94A3B8"/>
-                </a:solidFill>
-                <a:latin typeface="Inter"/>
-                <a:ea typeface="Inter"/>
-                <a:cs typeface="Inter"/>
-                <a:sym typeface="Inter"/>
-              </a:rPr>
-              <a:t>automatizada</a:t>
-            </a:r>
-            <a:r>
-              <a:rPr lang="en-US" sz="1425" b="0" i="0" u="none" strike="noStrike" cap="none" dirty="0">
-                <a:solidFill>
-                  <a:srgbClr val="94A3B8"/>
-                </a:solidFill>
-                <a:latin typeface="Inter"/>
-                <a:ea typeface="Inter"/>
-                <a:cs typeface="Inter"/>
-                <a:sym typeface="Inter"/>
-              </a:rPr>
-              <a:t> </a:t>
-            </a:r>
-            <a:r>
-              <a:rPr lang="en-US" sz="1425" b="0" i="0" u="none" strike="noStrike" cap="none" dirty="0" err="1">
-                <a:solidFill>
-                  <a:srgbClr val="94A3B8"/>
-                </a:solidFill>
-                <a:latin typeface="Inter"/>
-                <a:ea typeface="Inter"/>
-                <a:cs typeface="Inter"/>
-                <a:sym typeface="Inter"/>
-              </a:rPr>
-              <a:t>desde</a:t>
-            </a:r>
-            <a:r>
-              <a:rPr lang="en-US" sz="1425" b="0" i="0" u="none" strike="noStrike" cap="none" dirty="0">
-                <a:solidFill>
-                  <a:srgbClr val="94A3B8"/>
-                </a:solidFill>
-                <a:latin typeface="Inter"/>
-                <a:ea typeface="Inter"/>
-                <a:cs typeface="Inter"/>
-                <a:sym typeface="Inter"/>
-              </a:rPr>
-              <a:t> </a:t>
-            </a:r>
-            <a:r>
-              <a:rPr lang="en-US" sz="1425" b="0" i="0" u="none" strike="noStrike" cap="none" dirty="0" err="1">
-                <a:solidFill>
-                  <a:srgbClr val="94A3B8"/>
-                </a:solidFill>
-                <a:latin typeface="Inter"/>
-                <a:ea typeface="Inter"/>
-                <a:cs typeface="Inter"/>
-                <a:sym typeface="Inter"/>
-              </a:rPr>
-              <a:t>BoardGameGeek</a:t>
-            </a:r>
-            <a:r>
-              <a:rPr lang="en-US" sz="1425" b="0" i="0" u="none" strike="noStrike" cap="none" dirty="0">
-                <a:solidFill>
-                  <a:srgbClr val="94A3B8"/>
-                </a:solidFill>
-                <a:latin typeface="Inter"/>
-                <a:ea typeface="Inter"/>
-                <a:cs typeface="Inter"/>
-                <a:sym typeface="Inter"/>
-              </a:rPr>
-              <a:t>.</a:t>
-            </a:r>
-            <a:endParaRPr dirty="0"/>
+            <a:endParaRPr/>
           </a:p>
         </p:txBody>
       </p:sp>
       <p:sp>
         <p:nvSpPr>
-          <p:cNvPr id="258" name="Google Shape;258;p20"/>
+          <p:cNvPr id="299" name="Google Shape;299;p22"/>
           <p:cNvSpPr txBox="1"/>
           <p:nvPr/>
         </p:nvSpPr>
         <p:spPr>
           <a:xfrm>
-            <a:off x="4014787" y="4186237"/>
-            <a:ext cx="4543425" cy="289470"/>
+            <a:off x="962025" y="4104233"/>
+            <a:ext cx="4895850" cy="578941"/>
           </a:xfrm>
           <a:prstGeom prst="rect">
             <a:avLst/>
@@ -12613,7 +12746,7 @@
               <a:buNone/>
             </a:pPr>
             <a:r>
-              <a:rPr lang="en-US" sz="1425" b="0" i="0" u="none" strike="noStrike" cap="none" dirty="0">
+              <a:rPr lang="en-US" sz="1425" b="0" i="0" u="none" strike="noStrike" cap="none">
                 <a:solidFill>
                   <a:srgbClr val="94A3B8"/>
                 </a:solidFill>
@@ -12622,10 +12755,22 @@
                 <a:cs typeface="Inter"/>
                 <a:sym typeface="Inter"/>
               </a:rPr>
-              <a:t>2. </a:t>
+              <a:t>Manejo real de </a:t>
             </a:r>
             <a:r>
-              <a:rPr lang="en-US" sz="1425" b="0" i="0" u="none" strike="noStrike" cap="none" dirty="0" err="1">
+              <a:rPr lang="en-US" sz="1425" b="0" i="0" u="none" strike="noStrike" cap="none">
+                <a:solidFill>
+                  <a:srgbClr val="F8FAFC"/>
+                </a:solidFill>
+                <a:latin typeface="Inter SemiBold"/>
+                <a:ea typeface="Inter SemiBold"/>
+                <a:cs typeface="Inter SemiBold"/>
+                <a:sym typeface="Inter SemiBold"/>
+              </a:rPr>
+              <a:t>concurrencia y bases de datos</a:t>
+            </a:r>
+            <a:r>
+              <a:rPr lang="en-US" sz="1425" b="0" i="0" u="none" strike="noStrike" cap="none">
                 <a:solidFill>
                   <a:srgbClr val="94A3B8"/>
                 </a:solidFill>
@@ -12634,154 +12779,22 @@
                 <a:cs typeface="Inter"/>
                 <a:sym typeface="Inter"/>
               </a:rPr>
-              <a:t>Creación</a:t>
+              <a:t> transaccionales.</a:t>
             </a:r>
-            <a:r>
-              <a:rPr lang="en-US" sz="1425" b="0" i="0" u="none" strike="noStrike" cap="none" dirty="0">
-                <a:solidFill>
-                  <a:srgbClr val="94A3B8"/>
-                </a:solidFill>
-                <a:latin typeface="Inter"/>
-                <a:ea typeface="Inter"/>
-                <a:cs typeface="Inter"/>
-                <a:sym typeface="Inter"/>
-              </a:rPr>
-              <a:t> de un </a:t>
-            </a:r>
-            <a:r>
-              <a:rPr lang="en-US" sz="1425" b="0" i="0" u="none" strike="noStrike" cap="none" dirty="0" err="1">
-                <a:solidFill>
-                  <a:srgbClr val="94A3B8"/>
-                </a:solidFill>
-                <a:latin typeface="Inter"/>
-                <a:ea typeface="Inter"/>
-                <a:cs typeface="Inter"/>
-                <a:sym typeface="Inter"/>
-              </a:rPr>
-              <a:t>Ejemplar</a:t>
-            </a:r>
-            <a:r>
-              <a:rPr lang="en-US" sz="1425" b="0" i="0" u="none" strike="noStrike" cap="none" dirty="0">
-                <a:solidFill>
-                  <a:srgbClr val="94A3B8"/>
-                </a:solidFill>
-                <a:latin typeface="Inter"/>
-                <a:ea typeface="Inter"/>
-                <a:cs typeface="Inter"/>
-                <a:sym typeface="Inter"/>
-              </a:rPr>
-              <a:t> </a:t>
-            </a:r>
-            <a:r>
-              <a:rPr lang="en-US" sz="1425" b="0" i="0" u="none" strike="noStrike" cap="none" dirty="0" err="1">
-                <a:solidFill>
-                  <a:srgbClr val="94A3B8"/>
-                </a:solidFill>
-                <a:latin typeface="Inter"/>
-                <a:ea typeface="Inter"/>
-                <a:cs typeface="Inter"/>
-                <a:sym typeface="Inter"/>
-              </a:rPr>
-              <a:t>físico</a:t>
-            </a:r>
-            <a:r>
-              <a:rPr lang="en-US" sz="1425" b="0" i="0" u="none" strike="noStrike" cap="none" dirty="0">
-                <a:solidFill>
-                  <a:srgbClr val="94A3B8"/>
-                </a:solidFill>
-                <a:latin typeface="Inter"/>
-                <a:ea typeface="Inter"/>
-                <a:cs typeface="Inter"/>
-                <a:sym typeface="Inter"/>
-              </a:rPr>
-              <a:t> </a:t>
-            </a:r>
-            <a:r>
-              <a:rPr lang="en-US" sz="1425" b="0" i="0" u="none" strike="noStrike" cap="none" dirty="0" err="1">
-                <a:solidFill>
-                  <a:srgbClr val="94A3B8"/>
-                </a:solidFill>
-                <a:latin typeface="Inter"/>
-                <a:ea typeface="Inter"/>
-                <a:cs typeface="Inter"/>
-                <a:sym typeface="Inter"/>
-              </a:rPr>
-              <a:t>en</a:t>
-            </a:r>
-            <a:r>
-              <a:rPr lang="en-US" sz="1425" b="0" i="0" u="none" strike="noStrike" cap="none" dirty="0">
-                <a:solidFill>
-                  <a:srgbClr val="94A3B8"/>
-                </a:solidFill>
-                <a:latin typeface="Inter"/>
-                <a:ea typeface="Inter"/>
-                <a:cs typeface="Inter"/>
-                <a:sym typeface="Inter"/>
-              </a:rPr>
-              <a:t> </a:t>
-            </a:r>
-            <a:r>
-              <a:rPr lang="en-US" sz="1425" b="0" i="0" u="none" strike="noStrike" cap="none" dirty="0" err="1">
-                <a:solidFill>
-                  <a:srgbClr val="94A3B8"/>
-                </a:solidFill>
-                <a:latin typeface="Inter"/>
-                <a:ea typeface="Inter"/>
-                <a:cs typeface="Inter"/>
-                <a:sym typeface="Inter"/>
-              </a:rPr>
-              <a:t>el</a:t>
-            </a:r>
-            <a:r>
-              <a:rPr lang="en-US" sz="1425" b="0" i="0" u="none" strike="noStrike" cap="none" dirty="0">
-                <a:solidFill>
-                  <a:srgbClr val="94A3B8"/>
-                </a:solidFill>
-                <a:latin typeface="Inter"/>
-                <a:ea typeface="Inter"/>
-                <a:cs typeface="Inter"/>
-                <a:sym typeface="Inter"/>
-              </a:rPr>
-              <a:t> </a:t>
-            </a:r>
-            <a:r>
-              <a:rPr lang="en-US" sz="1425" b="0" i="0" u="none" strike="noStrike" cap="none" dirty="0" err="1">
-                <a:solidFill>
-                  <a:srgbClr val="94A3B8"/>
-                </a:solidFill>
-                <a:latin typeface="Inter"/>
-                <a:ea typeface="Inter"/>
-                <a:cs typeface="Inter"/>
-                <a:sym typeface="Inter"/>
-              </a:rPr>
-              <a:t>inventario</a:t>
-            </a:r>
-            <a:r>
-              <a:rPr lang="en-US" sz="1425" b="0" i="0" u="none" strike="noStrike" cap="none" dirty="0">
-                <a:solidFill>
-                  <a:srgbClr val="94A3B8"/>
-                </a:solidFill>
-                <a:latin typeface="Inter"/>
-                <a:ea typeface="Inter"/>
-                <a:cs typeface="Inter"/>
-                <a:sym typeface="Inter"/>
-              </a:rPr>
-              <a:t>.</a:t>
-            </a:r>
-            <a:endParaRPr dirty="0"/>
+            <a:endParaRPr/>
           </a:p>
         </p:txBody>
       </p:sp>
       <p:sp>
         <p:nvSpPr>
-          <p:cNvPr id="259" name="Google Shape;259;p20"/>
+          <p:cNvPr id="300" name="Google Shape;300;p22"/>
           <p:cNvSpPr txBox="1"/>
           <p:nvPr/>
         </p:nvSpPr>
         <p:spPr>
           <a:xfrm>
-            <a:off x="4014787" y="4618583"/>
-            <a:ext cx="4543425" cy="289470"/>
+            <a:off x="962025" y="4826049"/>
+            <a:ext cx="4895850" cy="578941"/>
           </a:xfrm>
           <a:prstGeom prst="rect">
             <a:avLst/>
@@ -12810,7 +12823,7 @@
               <a:buNone/>
             </a:pPr>
             <a:r>
-              <a:rPr lang="en-US" sz="1425" b="0" i="0" u="none" strike="noStrike" cap="none" dirty="0">
+              <a:rPr lang="en-US" sz="1425" b="0" i="0" u="none" strike="noStrike" cap="none">
                 <a:solidFill>
                   <a:srgbClr val="94A3B8"/>
                 </a:solidFill>
@@ -12819,10 +12832,22 @@
                 <a:cs typeface="Inter"/>
                 <a:sym typeface="Inter"/>
               </a:rPr>
-              <a:t>3. </a:t>
+              <a:t>Valor de escribir </a:t>
             </a:r>
             <a:r>
-              <a:rPr lang="en-US" sz="1425" b="0" i="0" u="none" strike="noStrike" cap="none" dirty="0" err="1">
+              <a:rPr lang="en-US" sz="1425" b="0" i="0" u="none" strike="noStrike" cap="none">
+                <a:solidFill>
+                  <a:srgbClr val="F8FAFC"/>
+                </a:solidFill>
+                <a:latin typeface="Inter SemiBold"/>
+                <a:ea typeface="Inter SemiBold"/>
+                <a:cs typeface="Inter SemiBold"/>
+                <a:sym typeface="Inter SemiBold"/>
+              </a:rPr>
+              <a:t>código limpio, escalable</a:t>
+            </a:r>
+            <a:r>
+              <a:rPr lang="en-US" sz="1425" b="0" i="0" u="none" strike="noStrike" cap="none">
                 <a:solidFill>
                   <a:srgbClr val="94A3B8"/>
                 </a:solidFill>
@@ -12831,117 +12856,9 @@
                 <a:cs typeface="Inter"/>
                 <a:sym typeface="Inter"/>
               </a:rPr>
-              <a:t>Filtrado</a:t>
+              <a:t> y protegido contra fallos externos (APIs).</a:t>
             </a:r>
-            <a:r>
-              <a:rPr lang="en-US" sz="1425" b="0" i="0" u="none" strike="noStrike" cap="none" dirty="0">
-                <a:solidFill>
-                  <a:srgbClr val="94A3B8"/>
-                </a:solidFill>
-                <a:latin typeface="Inter"/>
-                <a:ea typeface="Inter"/>
-                <a:cs typeface="Inter"/>
-                <a:sym typeface="Inter"/>
-              </a:rPr>
-              <a:t> </a:t>
-            </a:r>
-            <a:r>
-              <a:rPr lang="en-US" sz="1425" b="0" i="0" u="none" strike="noStrike" cap="none" dirty="0" err="1">
-                <a:solidFill>
-                  <a:srgbClr val="94A3B8"/>
-                </a:solidFill>
-                <a:latin typeface="Inter"/>
-                <a:ea typeface="Inter"/>
-                <a:cs typeface="Inter"/>
-                <a:sym typeface="Inter"/>
-              </a:rPr>
-              <a:t>reactivo</a:t>
-            </a:r>
-            <a:r>
-              <a:rPr lang="en-US" sz="1425" b="0" i="0" u="none" strike="noStrike" cap="none" dirty="0">
-                <a:solidFill>
-                  <a:srgbClr val="94A3B8"/>
-                </a:solidFill>
-                <a:latin typeface="Inter"/>
-                <a:ea typeface="Inter"/>
-                <a:cs typeface="Inter"/>
-                <a:sym typeface="Inter"/>
-              </a:rPr>
-              <a:t> Zero-Lag </a:t>
-            </a:r>
-            <a:r>
-              <a:rPr lang="en-US" sz="1425" b="0" i="0" u="none" strike="noStrike" cap="none" dirty="0" err="1">
-                <a:solidFill>
-                  <a:srgbClr val="94A3B8"/>
-                </a:solidFill>
-                <a:latin typeface="Inter"/>
-                <a:ea typeface="Inter"/>
-                <a:cs typeface="Inter"/>
-                <a:sym typeface="Inter"/>
-              </a:rPr>
-              <a:t>en</a:t>
-            </a:r>
-            <a:r>
-              <a:rPr lang="en-US" sz="1425" b="0" i="0" u="none" strike="noStrike" cap="none" dirty="0">
-                <a:solidFill>
-                  <a:srgbClr val="94A3B8"/>
-                </a:solidFill>
-                <a:latin typeface="Inter"/>
-                <a:ea typeface="Inter"/>
-                <a:cs typeface="Inter"/>
-                <a:sym typeface="Inter"/>
-              </a:rPr>
-              <a:t> </a:t>
-            </a:r>
-            <a:r>
-              <a:rPr lang="en-US" sz="1425" b="0" i="0" u="none" strike="noStrike" cap="none" dirty="0" err="1">
-                <a:solidFill>
-                  <a:srgbClr val="94A3B8"/>
-                </a:solidFill>
-                <a:latin typeface="Inter"/>
-                <a:ea typeface="Inter"/>
-                <a:cs typeface="Inter"/>
-                <a:sym typeface="Inter"/>
-              </a:rPr>
-              <a:t>el</a:t>
-            </a:r>
-            <a:r>
-              <a:rPr lang="en-US" sz="1425" b="0" i="0" u="none" strike="noStrike" cap="none" dirty="0">
-                <a:solidFill>
-                  <a:srgbClr val="94A3B8"/>
-                </a:solidFill>
-                <a:latin typeface="Inter"/>
-                <a:ea typeface="Inter"/>
-                <a:cs typeface="Inter"/>
-                <a:sym typeface="Inter"/>
-              </a:rPr>
-              <a:t> </a:t>
-            </a:r>
-            <a:r>
-              <a:rPr lang="en-US" sz="1425" b="0" i="0" u="none" strike="noStrike" cap="none" dirty="0" err="1">
-                <a:solidFill>
-                  <a:srgbClr val="94A3B8"/>
-                </a:solidFill>
-                <a:latin typeface="Inter"/>
-                <a:ea typeface="Inter"/>
-                <a:cs typeface="Inter"/>
-                <a:sym typeface="Inter"/>
-              </a:rPr>
-              <a:t>catálogo</a:t>
-            </a:r>
-            <a:r>
-              <a:rPr lang="en-US" sz="1425" b="0" i="0" u="none" strike="noStrike" cap="none" dirty="0">
-                <a:solidFill>
-                  <a:srgbClr val="94A3B8"/>
-                </a:solidFill>
-                <a:latin typeface="Inter"/>
-                <a:ea typeface="Inter"/>
-                <a:cs typeface="Inter"/>
-                <a:sym typeface="Inter"/>
-              </a:rPr>
-              <a:t> principal.</a:t>
-            </a:r>
-            <a:endParaRPr dirty="0"/>
+            <a:endParaRPr/>
           </a:p>
         </p:txBody>
       </p:sp>
@@ -19498,6 +19415,896 @@
     <p:bg>
       <p:bgPr>
         <a:solidFill>
+          <a:srgbClr val="05080F"/>
+        </a:solidFill>
+        <a:effectLst/>
+      </p:bgPr>
+    </p:bg>
+    <p:spTree>
+      <p:nvGrpSpPr>
+        <p:cNvPr id="1" name="Shape 246"/>
+        <p:cNvGrpSpPr/>
+        <p:nvPr/>
+      </p:nvGrpSpPr>
+      <p:grpSpPr>
+        <a:xfrm>
+          <a:off x="0" y="0"/>
+          <a:ext cx="0" cy="0"/>
+          <a:chOff x="0" y="0"/>
+          <a:chExt cx="0" cy="0"/>
+        </a:xfrm>
+      </p:grpSpPr>
+      <p:pic>
+        <p:nvPicPr>
+          <p:cNvPr id="247" name="Google Shape;247;p20" descr="image.png"/>
+          <p:cNvPicPr preferRelativeResize="0"/>
+          <p:nvPr/>
+        </p:nvPicPr>
+        <p:blipFill rotWithShape="1">
+          <a:blip r:embed="rId3">
+            <a:alphaModFix/>
+          </a:blip>
+          <a:srcRect/>
+          <a:stretch/>
+        </p:blipFill>
+        <p:spPr>
+          <a:xfrm>
+            <a:off x="0" y="0"/>
+            <a:ext cx="12192000" cy="6858000"/>
+          </a:xfrm>
+          <a:prstGeom prst="rect">
+            <a:avLst/>
+          </a:prstGeom>
+          <a:noFill/>
+          <a:ln>
+            <a:noFill/>
+          </a:ln>
+        </p:spPr>
+      </p:pic>
+      <p:pic>
+        <p:nvPicPr>
+          <p:cNvPr id="249" name="Google Shape;249;p20" descr="image.png"/>
+          <p:cNvPicPr preferRelativeResize="0"/>
+          <p:nvPr/>
+        </p:nvPicPr>
+        <p:blipFill rotWithShape="1">
+          <a:blip r:embed="rId4">
+            <a:alphaModFix/>
+          </a:blip>
+          <a:srcRect/>
+          <a:stretch/>
+        </p:blipFill>
+        <p:spPr>
+          <a:xfrm>
+            <a:off x="581025" y="6248400"/>
+            <a:ext cx="11029950" cy="314325"/>
+          </a:xfrm>
+          <a:prstGeom prst="rect">
+            <a:avLst/>
+          </a:prstGeom>
+          <a:noFill/>
+          <a:ln>
+            <a:noFill/>
+          </a:ln>
+        </p:spPr>
+      </p:pic>
+      <p:sp>
+        <p:nvSpPr>
+          <p:cNvPr id="250" name="Google Shape;250;p20"/>
+          <p:cNvSpPr txBox="1"/>
+          <p:nvPr/>
+        </p:nvSpPr>
+        <p:spPr>
+          <a:xfrm>
+            <a:off x="581025" y="6400800"/>
+            <a:ext cx="1495425" cy="161925"/>
+          </a:xfrm>
+          <a:prstGeom prst="rect">
+            <a:avLst/>
+          </a:prstGeom>
+          <a:noFill/>
+          <a:ln>
+            <a:noFill/>
+          </a:ln>
+        </p:spPr>
+        <p:txBody>
+          <a:bodyPr spcFirstLastPara="1" wrap="square" lIns="0" tIns="0" rIns="0" bIns="0" anchor="t" anchorCtr="0">
+            <a:spAutoFit/>
+          </a:bodyPr>
+          <a:lstStyle/>
+          <a:p>
+            <a:pPr marL="0" marR="0" lvl="0" indent="0" algn="ctr" rtl="0">
+              <a:spcBef>
+                <a:spcPts val="0"/>
+              </a:spcBef>
+              <a:spcAft>
+                <a:spcPts val="0"/>
+              </a:spcAft>
+              <a:buNone/>
+            </a:pPr>
+            <a:r>
+              <a:rPr lang="en-US" sz="1050" b="0" i="0" u="none" strike="noStrike" cap="none">
+                <a:solidFill>
+                  <a:srgbClr val="94A3B8"/>
+                </a:solidFill>
+                <a:latin typeface="Inter"/>
+                <a:ea typeface="Inter"/>
+                <a:cs typeface="Inter"/>
+                <a:sym typeface="Inter"/>
+              </a:rPr>
+              <a:t>LudiGest - Defensa TFG</a:t>
+            </a:r>
+            <a:endParaRPr/>
+          </a:p>
+        </p:txBody>
+      </p:sp>
+      <p:sp>
+        <p:nvSpPr>
+          <p:cNvPr id="251" name="Google Shape;251;p20"/>
+          <p:cNvSpPr txBox="1"/>
+          <p:nvPr/>
+        </p:nvSpPr>
+        <p:spPr>
+          <a:xfrm>
+            <a:off x="9372600" y="6400800"/>
+            <a:ext cx="2238375" cy="161925"/>
+          </a:xfrm>
+          <a:prstGeom prst="rect">
+            <a:avLst/>
+          </a:prstGeom>
+          <a:noFill/>
+          <a:ln>
+            <a:noFill/>
+          </a:ln>
+        </p:spPr>
+        <p:txBody>
+          <a:bodyPr spcFirstLastPara="1" wrap="square" lIns="0" tIns="0" rIns="0" bIns="0" anchor="t" anchorCtr="0">
+            <a:spAutoFit/>
+          </a:bodyPr>
+          <a:lstStyle/>
+          <a:p>
+            <a:pPr marL="0" marR="0" lvl="0" indent="0" algn="ctr" rtl="0">
+              <a:spcBef>
+                <a:spcPts val="0"/>
+              </a:spcBef>
+              <a:spcAft>
+                <a:spcPts val="0"/>
+              </a:spcAft>
+              <a:buNone/>
+            </a:pPr>
+            <a:r>
+              <a:rPr lang="en-US" sz="1050" b="0" i="0" u="none" strike="noStrike" cap="none">
+                <a:solidFill>
+                  <a:srgbClr val="94A3B8"/>
+                </a:solidFill>
+                <a:latin typeface="Inter"/>
+                <a:ea typeface="Inter"/>
+                <a:cs typeface="Inter"/>
+                <a:sym typeface="Inter"/>
+              </a:rPr>
+              <a:t>Demostración Práctica (Máx. 2 min)</a:t>
+            </a:r>
+            <a:endParaRPr/>
+          </a:p>
+        </p:txBody>
+      </p:sp>
+      <p:pic>
+        <p:nvPicPr>
+          <p:cNvPr id="252" name="Google Shape;252;p20" descr="image.png"/>
+          <p:cNvPicPr preferRelativeResize="0"/>
+          <p:nvPr/>
+        </p:nvPicPr>
+        <p:blipFill rotWithShape="1">
+          <a:blip r:embed="rId5">
+            <a:alphaModFix/>
+          </a:blip>
+          <a:srcRect/>
+          <a:stretch/>
+        </p:blipFill>
+        <p:spPr>
+          <a:xfrm>
+            <a:off x="3633787" y="3796754"/>
+            <a:ext cx="142875" cy="200025"/>
+          </a:xfrm>
+          <a:prstGeom prst="rect">
+            <a:avLst/>
+          </a:prstGeom>
+          <a:noFill/>
+          <a:ln>
+            <a:noFill/>
+          </a:ln>
+        </p:spPr>
+      </p:pic>
+      <p:pic>
+        <p:nvPicPr>
+          <p:cNvPr id="253" name="Google Shape;253;p20" descr="image.png"/>
+          <p:cNvPicPr preferRelativeResize="0"/>
+          <p:nvPr/>
+        </p:nvPicPr>
+        <p:blipFill rotWithShape="1">
+          <a:blip r:embed="rId5">
+            <a:alphaModFix/>
+          </a:blip>
+          <a:srcRect/>
+          <a:stretch/>
+        </p:blipFill>
+        <p:spPr>
+          <a:xfrm>
+            <a:off x="3633787" y="4229100"/>
+            <a:ext cx="142875" cy="200025"/>
+          </a:xfrm>
+          <a:prstGeom prst="rect">
+            <a:avLst/>
+          </a:prstGeom>
+          <a:noFill/>
+          <a:ln>
+            <a:noFill/>
+          </a:ln>
+        </p:spPr>
+      </p:pic>
+      <p:pic>
+        <p:nvPicPr>
+          <p:cNvPr id="254" name="Google Shape;254;p20" descr="image.png"/>
+          <p:cNvPicPr preferRelativeResize="0"/>
+          <p:nvPr/>
+        </p:nvPicPr>
+        <p:blipFill rotWithShape="1">
+          <a:blip r:embed="rId5">
+            <a:alphaModFix/>
+          </a:blip>
+          <a:srcRect/>
+          <a:stretch/>
+        </p:blipFill>
+        <p:spPr>
+          <a:xfrm>
+            <a:off x="3633787" y="4661445"/>
+            <a:ext cx="142875" cy="200025"/>
+          </a:xfrm>
+          <a:prstGeom prst="rect">
+            <a:avLst/>
+          </a:prstGeom>
+          <a:noFill/>
+          <a:ln>
+            <a:noFill/>
+          </a:ln>
+        </p:spPr>
+      </p:pic>
+      <p:sp>
+        <p:nvSpPr>
+          <p:cNvPr id="255" name="Google Shape;255;p20"/>
+          <p:cNvSpPr txBox="1"/>
+          <p:nvPr/>
+        </p:nvSpPr>
+        <p:spPr>
+          <a:xfrm>
+            <a:off x="1365408" y="1807071"/>
+            <a:ext cx="9461182" cy="1009650"/>
+          </a:xfrm>
+          <a:prstGeom prst="rect">
+            <a:avLst/>
+          </a:prstGeom>
+          <a:noFill/>
+          <a:ln>
+            <a:noFill/>
+          </a:ln>
+        </p:spPr>
+        <p:txBody>
+          <a:bodyPr spcFirstLastPara="1" wrap="square" lIns="0" tIns="0" rIns="0" bIns="0" anchor="t" anchorCtr="0">
+            <a:spAutoFit/>
+          </a:bodyPr>
+          <a:lstStyle/>
+          <a:p>
+            <a:pPr marL="0" marR="0" lvl="0" indent="0" algn="ctr" rtl="0">
+              <a:spcBef>
+                <a:spcPts val="0"/>
+              </a:spcBef>
+              <a:spcAft>
+                <a:spcPts val="0"/>
+              </a:spcAft>
+              <a:buNone/>
+            </a:pPr>
+            <a:r>
+              <a:rPr lang="en-US" sz="5250" b="1" i="0" u="none" strike="noStrike" cap="none">
+                <a:solidFill>
+                  <a:srgbClr val="0EA5E9"/>
+                </a:solidFill>
+                <a:latin typeface="Poppins"/>
+                <a:ea typeface="Poppins"/>
+                <a:cs typeface="Poppins"/>
+                <a:sym typeface="Poppins"/>
+              </a:rPr>
+              <a:t>6. DEMOSTRACIÓN EN VIVO</a:t>
+            </a:r>
+            <a:endParaRPr/>
+          </a:p>
+        </p:txBody>
+      </p:sp>
+      <p:sp>
+        <p:nvSpPr>
+          <p:cNvPr id="256" name="Google Shape;256;p20"/>
+          <p:cNvSpPr txBox="1"/>
+          <p:nvPr/>
+        </p:nvSpPr>
+        <p:spPr>
+          <a:xfrm>
+            <a:off x="4552950" y="3007221"/>
+            <a:ext cx="3086100" cy="365670"/>
+          </a:xfrm>
+          <a:prstGeom prst="rect">
+            <a:avLst/>
+          </a:prstGeom>
+          <a:noFill/>
+          <a:ln>
+            <a:noFill/>
+          </a:ln>
+        </p:spPr>
+        <p:txBody>
+          <a:bodyPr spcFirstLastPara="1" wrap="square" lIns="0" tIns="0" rIns="0" bIns="0" anchor="t" anchorCtr="0">
+            <a:spAutoFit/>
+          </a:bodyPr>
+          <a:lstStyle/>
+          <a:p>
+            <a:pPr marL="0" marR="0" lvl="0" indent="0" algn="ctr" rtl="0">
+              <a:lnSpc>
+                <a:spcPct val="159944"/>
+              </a:lnSpc>
+              <a:spcBef>
+                <a:spcPts val="0"/>
+              </a:spcBef>
+              <a:spcAft>
+                <a:spcPts val="0"/>
+              </a:spcAft>
+              <a:buNone/>
+            </a:pPr>
+            <a:r>
+              <a:rPr lang="en-US" sz="1800" b="0" i="0" u="none" strike="noStrike" cap="none">
+                <a:solidFill>
+                  <a:srgbClr val="F8FAFC"/>
+                </a:solidFill>
+                <a:latin typeface="Inter"/>
+                <a:ea typeface="Inter"/>
+                <a:cs typeface="Inter"/>
+                <a:sym typeface="Inter"/>
+              </a:rPr>
+              <a:t>Flujo Completo de Ejecución</a:t>
+            </a:r>
+            <a:endParaRPr/>
+          </a:p>
+        </p:txBody>
+      </p:sp>
+      <p:sp>
+        <p:nvSpPr>
+          <p:cNvPr id="257" name="Google Shape;257;p20"/>
+          <p:cNvSpPr txBox="1"/>
+          <p:nvPr/>
+        </p:nvSpPr>
+        <p:spPr>
+          <a:xfrm>
+            <a:off x="4014787" y="3753891"/>
+            <a:ext cx="4543425" cy="289470"/>
+          </a:xfrm>
+          <a:prstGeom prst="rect">
+            <a:avLst/>
+          </a:prstGeom>
+          <a:noFill/>
+          <a:ln>
+            <a:noFill/>
+          </a:ln>
+        </p:spPr>
+        <p:txBody>
+          <a:bodyPr spcFirstLastPara="1" wrap="square" lIns="0" tIns="0" rIns="0" bIns="0" anchor="t" anchorCtr="0">
+            <a:spAutoFit/>
+          </a:bodyPr>
+          <a:lstStyle/>
+          <a:p>
+            <a:pPr marL="0" marR="0" lvl="0" indent="0" algn="l" rtl="0">
+              <a:lnSpc>
+                <a:spcPct val="159929"/>
+              </a:lnSpc>
+              <a:spcBef>
+                <a:spcPts val="0"/>
+              </a:spcBef>
+              <a:spcAft>
+                <a:spcPts val="0"/>
+              </a:spcAft>
+              <a:buNone/>
+            </a:pPr>
+            <a:r>
+              <a:rPr lang="en-US" sz="1425" b="0" i="0" u="none" strike="noStrike" cap="none" dirty="0">
+                <a:solidFill>
+                  <a:srgbClr val="94A3B8"/>
+                </a:solidFill>
+                <a:latin typeface="Inter"/>
+                <a:ea typeface="Inter"/>
+                <a:cs typeface="Inter"/>
+                <a:sym typeface="Inter"/>
+              </a:rPr>
+              <a:t>1. </a:t>
+            </a:r>
+            <a:r>
+              <a:rPr lang="en-US" sz="1425" b="0" i="0" u="none" strike="noStrike" cap="none" dirty="0" err="1">
+                <a:solidFill>
+                  <a:srgbClr val="94A3B8"/>
+                </a:solidFill>
+                <a:latin typeface="Inter"/>
+                <a:ea typeface="Inter"/>
+                <a:cs typeface="Inter"/>
+                <a:sym typeface="Inter"/>
+              </a:rPr>
+              <a:t>Importación</a:t>
+            </a:r>
+            <a:r>
+              <a:rPr lang="en-US" sz="1425" b="0" i="0" u="none" strike="noStrike" cap="none" dirty="0">
+                <a:solidFill>
+                  <a:srgbClr val="94A3B8"/>
+                </a:solidFill>
+                <a:latin typeface="Inter"/>
+                <a:ea typeface="Inter"/>
+                <a:cs typeface="Inter"/>
+                <a:sym typeface="Inter"/>
+              </a:rPr>
+              <a:t> </a:t>
+            </a:r>
+            <a:r>
+              <a:rPr lang="en-US" sz="1425" b="0" i="0" u="none" strike="noStrike" cap="none" dirty="0" err="1">
+                <a:solidFill>
+                  <a:srgbClr val="94A3B8"/>
+                </a:solidFill>
+                <a:latin typeface="Inter"/>
+                <a:ea typeface="Inter"/>
+                <a:cs typeface="Inter"/>
+                <a:sym typeface="Inter"/>
+              </a:rPr>
+              <a:t>automatizada</a:t>
+            </a:r>
+            <a:r>
+              <a:rPr lang="en-US" sz="1425" b="0" i="0" u="none" strike="noStrike" cap="none" dirty="0">
+                <a:solidFill>
+                  <a:srgbClr val="94A3B8"/>
+                </a:solidFill>
+                <a:latin typeface="Inter"/>
+                <a:ea typeface="Inter"/>
+                <a:cs typeface="Inter"/>
+                <a:sym typeface="Inter"/>
+              </a:rPr>
+              <a:t> </a:t>
+            </a:r>
+            <a:r>
+              <a:rPr lang="en-US" sz="1425" b="0" i="0" u="none" strike="noStrike" cap="none" dirty="0" err="1">
+                <a:solidFill>
+                  <a:srgbClr val="94A3B8"/>
+                </a:solidFill>
+                <a:latin typeface="Inter"/>
+                <a:ea typeface="Inter"/>
+                <a:cs typeface="Inter"/>
+                <a:sym typeface="Inter"/>
+              </a:rPr>
+              <a:t>desde</a:t>
+            </a:r>
+            <a:r>
+              <a:rPr lang="en-US" sz="1425" b="0" i="0" u="none" strike="noStrike" cap="none" dirty="0">
+                <a:solidFill>
+                  <a:srgbClr val="94A3B8"/>
+                </a:solidFill>
+                <a:latin typeface="Inter"/>
+                <a:ea typeface="Inter"/>
+                <a:cs typeface="Inter"/>
+                <a:sym typeface="Inter"/>
+              </a:rPr>
+              <a:t> </a:t>
+            </a:r>
+            <a:r>
+              <a:rPr lang="en-US" sz="1425" b="0" i="0" u="none" strike="noStrike" cap="none" dirty="0" err="1">
+                <a:solidFill>
+                  <a:srgbClr val="94A3B8"/>
+                </a:solidFill>
+                <a:latin typeface="Inter"/>
+                <a:ea typeface="Inter"/>
+                <a:cs typeface="Inter"/>
+                <a:sym typeface="Inter"/>
+              </a:rPr>
+              <a:t>BoardGameGeek</a:t>
+            </a:r>
+            <a:r>
+              <a:rPr lang="en-US" sz="1425" b="0" i="0" u="none" strike="noStrike" cap="none" dirty="0">
+                <a:solidFill>
+                  <a:srgbClr val="94A3B8"/>
+                </a:solidFill>
+                <a:latin typeface="Inter"/>
+                <a:ea typeface="Inter"/>
+                <a:cs typeface="Inter"/>
+                <a:sym typeface="Inter"/>
+              </a:rPr>
+              <a:t>.</a:t>
+            </a:r>
+            <a:endParaRPr dirty="0"/>
+          </a:p>
+        </p:txBody>
+      </p:sp>
+      <p:sp>
+        <p:nvSpPr>
+          <p:cNvPr id="258" name="Google Shape;258;p20"/>
+          <p:cNvSpPr txBox="1"/>
+          <p:nvPr/>
+        </p:nvSpPr>
+        <p:spPr>
+          <a:xfrm>
+            <a:off x="4014787" y="4186237"/>
+            <a:ext cx="4543425" cy="289470"/>
+          </a:xfrm>
+          <a:prstGeom prst="rect">
+            <a:avLst/>
+          </a:prstGeom>
+          <a:noFill/>
+          <a:ln>
+            <a:noFill/>
+          </a:ln>
+        </p:spPr>
+        <p:txBody>
+          <a:bodyPr spcFirstLastPara="1" wrap="square" lIns="0" tIns="0" rIns="0" bIns="0" anchor="t" anchorCtr="0">
+            <a:spAutoFit/>
+          </a:bodyPr>
+          <a:lstStyle/>
+          <a:p>
+            <a:pPr marL="0" marR="0" lvl="0" indent="0" algn="l" rtl="0">
+              <a:lnSpc>
+                <a:spcPct val="159929"/>
+              </a:lnSpc>
+              <a:spcBef>
+                <a:spcPts val="0"/>
+              </a:spcBef>
+              <a:spcAft>
+                <a:spcPts val="0"/>
+              </a:spcAft>
+              <a:buNone/>
+            </a:pPr>
+            <a:r>
+              <a:rPr lang="en-US" sz="1425" b="0" i="0" u="none" strike="noStrike" cap="none" dirty="0">
+                <a:solidFill>
+                  <a:srgbClr val="94A3B8"/>
+                </a:solidFill>
+                <a:latin typeface="Inter"/>
+                <a:ea typeface="Inter"/>
+                <a:cs typeface="Inter"/>
+                <a:sym typeface="Inter"/>
+              </a:rPr>
+              <a:t>2. </a:t>
+            </a:r>
+            <a:r>
+              <a:rPr lang="en-US" sz="1425" b="0" i="0" u="none" strike="noStrike" cap="none" dirty="0" err="1">
+                <a:solidFill>
+                  <a:srgbClr val="94A3B8"/>
+                </a:solidFill>
+                <a:latin typeface="Inter"/>
+                <a:ea typeface="Inter"/>
+                <a:cs typeface="Inter"/>
+                <a:sym typeface="Inter"/>
+              </a:rPr>
+              <a:t>Creación</a:t>
+            </a:r>
+            <a:r>
+              <a:rPr lang="en-US" sz="1425" b="0" i="0" u="none" strike="noStrike" cap="none" dirty="0">
+                <a:solidFill>
+                  <a:srgbClr val="94A3B8"/>
+                </a:solidFill>
+                <a:latin typeface="Inter"/>
+                <a:ea typeface="Inter"/>
+                <a:cs typeface="Inter"/>
+                <a:sym typeface="Inter"/>
+              </a:rPr>
+              <a:t> de un </a:t>
+            </a:r>
+            <a:r>
+              <a:rPr lang="en-US" sz="1425" b="0" i="0" u="none" strike="noStrike" cap="none" dirty="0" err="1">
+                <a:solidFill>
+                  <a:srgbClr val="94A3B8"/>
+                </a:solidFill>
+                <a:latin typeface="Inter"/>
+                <a:ea typeface="Inter"/>
+                <a:cs typeface="Inter"/>
+                <a:sym typeface="Inter"/>
+              </a:rPr>
+              <a:t>Ejemplar</a:t>
+            </a:r>
+            <a:r>
+              <a:rPr lang="en-US" sz="1425" b="0" i="0" u="none" strike="noStrike" cap="none" dirty="0">
+                <a:solidFill>
+                  <a:srgbClr val="94A3B8"/>
+                </a:solidFill>
+                <a:latin typeface="Inter"/>
+                <a:ea typeface="Inter"/>
+                <a:cs typeface="Inter"/>
+                <a:sym typeface="Inter"/>
+              </a:rPr>
+              <a:t> </a:t>
+            </a:r>
+            <a:r>
+              <a:rPr lang="en-US" sz="1425" b="0" i="0" u="none" strike="noStrike" cap="none" dirty="0" err="1">
+                <a:solidFill>
+                  <a:srgbClr val="94A3B8"/>
+                </a:solidFill>
+                <a:latin typeface="Inter"/>
+                <a:ea typeface="Inter"/>
+                <a:cs typeface="Inter"/>
+                <a:sym typeface="Inter"/>
+              </a:rPr>
+              <a:t>físico</a:t>
+            </a:r>
+            <a:r>
+              <a:rPr lang="en-US" sz="1425" b="0" i="0" u="none" strike="noStrike" cap="none" dirty="0">
+                <a:solidFill>
+                  <a:srgbClr val="94A3B8"/>
+                </a:solidFill>
+                <a:latin typeface="Inter"/>
+                <a:ea typeface="Inter"/>
+                <a:cs typeface="Inter"/>
+                <a:sym typeface="Inter"/>
+              </a:rPr>
+              <a:t> </a:t>
+            </a:r>
+            <a:r>
+              <a:rPr lang="en-US" sz="1425" b="0" i="0" u="none" strike="noStrike" cap="none" dirty="0" err="1">
+                <a:solidFill>
+                  <a:srgbClr val="94A3B8"/>
+                </a:solidFill>
+                <a:latin typeface="Inter"/>
+                <a:ea typeface="Inter"/>
+                <a:cs typeface="Inter"/>
+                <a:sym typeface="Inter"/>
+              </a:rPr>
+              <a:t>en</a:t>
+            </a:r>
+            <a:r>
+              <a:rPr lang="en-US" sz="1425" b="0" i="0" u="none" strike="noStrike" cap="none" dirty="0">
+                <a:solidFill>
+                  <a:srgbClr val="94A3B8"/>
+                </a:solidFill>
+                <a:latin typeface="Inter"/>
+                <a:ea typeface="Inter"/>
+                <a:cs typeface="Inter"/>
+                <a:sym typeface="Inter"/>
+              </a:rPr>
+              <a:t> </a:t>
+            </a:r>
+            <a:r>
+              <a:rPr lang="en-US" sz="1425" b="0" i="0" u="none" strike="noStrike" cap="none" dirty="0" err="1">
+                <a:solidFill>
+                  <a:srgbClr val="94A3B8"/>
+                </a:solidFill>
+                <a:latin typeface="Inter"/>
+                <a:ea typeface="Inter"/>
+                <a:cs typeface="Inter"/>
+                <a:sym typeface="Inter"/>
+              </a:rPr>
+              <a:t>el</a:t>
+            </a:r>
+            <a:r>
+              <a:rPr lang="en-US" sz="1425" b="0" i="0" u="none" strike="noStrike" cap="none" dirty="0">
+                <a:solidFill>
+                  <a:srgbClr val="94A3B8"/>
+                </a:solidFill>
+                <a:latin typeface="Inter"/>
+                <a:ea typeface="Inter"/>
+                <a:cs typeface="Inter"/>
+                <a:sym typeface="Inter"/>
+              </a:rPr>
+              <a:t> </a:t>
+            </a:r>
+            <a:r>
+              <a:rPr lang="en-US" sz="1425" b="0" i="0" u="none" strike="noStrike" cap="none" dirty="0" err="1">
+                <a:solidFill>
+                  <a:srgbClr val="94A3B8"/>
+                </a:solidFill>
+                <a:latin typeface="Inter"/>
+                <a:ea typeface="Inter"/>
+                <a:cs typeface="Inter"/>
+                <a:sym typeface="Inter"/>
+              </a:rPr>
+              <a:t>inventario</a:t>
+            </a:r>
+            <a:r>
+              <a:rPr lang="en-US" sz="1425" b="0" i="0" u="none" strike="noStrike" cap="none" dirty="0">
+                <a:solidFill>
+                  <a:srgbClr val="94A3B8"/>
+                </a:solidFill>
+                <a:latin typeface="Inter"/>
+                <a:ea typeface="Inter"/>
+                <a:cs typeface="Inter"/>
+                <a:sym typeface="Inter"/>
+              </a:rPr>
+              <a:t>.</a:t>
+            </a:r>
+            <a:endParaRPr dirty="0"/>
+          </a:p>
+        </p:txBody>
+      </p:sp>
+      <p:sp>
+        <p:nvSpPr>
+          <p:cNvPr id="259" name="Google Shape;259;p20"/>
+          <p:cNvSpPr txBox="1"/>
+          <p:nvPr/>
+        </p:nvSpPr>
+        <p:spPr>
+          <a:xfrm>
+            <a:off x="4014787" y="4618583"/>
+            <a:ext cx="4543425" cy="289470"/>
+          </a:xfrm>
+          <a:prstGeom prst="rect">
+            <a:avLst/>
+          </a:prstGeom>
+          <a:noFill/>
+          <a:ln>
+            <a:noFill/>
+          </a:ln>
+        </p:spPr>
+        <p:txBody>
+          <a:bodyPr spcFirstLastPara="1" wrap="square" lIns="0" tIns="0" rIns="0" bIns="0" anchor="t" anchorCtr="0">
+            <a:spAutoFit/>
+          </a:bodyPr>
+          <a:lstStyle/>
+          <a:p>
+            <a:pPr marL="0" marR="0" lvl="0" indent="0" algn="l" rtl="0">
+              <a:lnSpc>
+                <a:spcPct val="159929"/>
+              </a:lnSpc>
+              <a:spcBef>
+                <a:spcPts val="0"/>
+              </a:spcBef>
+              <a:spcAft>
+                <a:spcPts val="0"/>
+              </a:spcAft>
+              <a:buNone/>
+            </a:pPr>
+            <a:r>
+              <a:rPr lang="en-US" sz="1425" b="0" i="0" u="none" strike="noStrike" cap="none" dirty="0">
+                <a:solidFill>
+                  <a:srgbClr val="94A3B8"/>
+                </a:solidFill>
+                <a:latin typeface="Inter"/>
+                <a:ea typeface="Inter"/>
+                <a:cs typeface="Inter"/>
+                <a:sym typeface="Inter"/>
+              </a:rPr>
+              <a:t>3. </a:t>
+            </a:r>
+            <a:r>
+              <a:rPr lang="en-US" sz="1425" b="0" i="0" u="none" strike="noStrike" cap="none" dirty="0" err="1">
+                <a:solidFill>
+                  <a:srgbClr val="94A3B8"/>
+                </a:solidFill>
+                <a:latin typeface="Inter"/>
+                <a:ea typeface="Inter"/>
+                <a:cs typeface="Inter"/>
+                <a:sym typeface="Inter"/>
+              </a:rPr>
+              <a:t>Filtrado</a:t>
+            </a:r>
+            <a:r>
+              <a:rPr lang="en-US" sz="1425" b="0" i="0" u="none" strike="noStrike" cap="none" dirty="0">
+                <a:solidFill>
+                  <a:srgbClr val="94A3B8"/>
+                </a:solidFill>
+                <a:latin typeface="Inter"/>
+                <a:ea typeface="Inter"/>
+                <a:cs typeface="Inter"/>
+                <a:sym typeface="Inter"/>
+              </a:rPr>
+              <a:t> </a:t>
+            </a:r>
+            <a:r>
+              <a:rPr lang="en-US" sz="1425" b="0" i="0" u="none" strike="noStrike" cap="none" dirty="0" err="1">
+                <a:solidFill>
+                  <a:srgbClr val="94A3B8"/>
+                </a:solidFill>
+                <a:latin typeface="Inter"/>
+                <a:ea typeface="Inter"/>
+                <a:cs typeface="Inter"/>
+                <a:sym typeface="Inter"/>
+              </a:rPr>
+              <a:t>reactivo</a:t>
+            </a:r>
+            <a:r>
+              <a:rPr lang="en-US" sz="1425" b="0" i="0" u="none" strike="noStrike" cap="none" dirty="0">
+                <a:solidFill>
+                  <a:srgbClr val="94A3B8"/>
+                </a:solidFill>
+                <a:latin typeface="Inter"/>
+                <a:ea typeface="Inter"/>
+                <a:cs typeface="Inter"/>
+                <a:sym typeface="Inter"/>
+              </a:rPr>
+              <a:t> Zero-Lag </a:t>
+            </a:r>
+            <a:r>
+              <a:rPr lang="en-US" sz="1425" b="0" i="0" u="none" strike="noStrike" cap="none" dirty="0" err="1">
+                <a:solidFill>
+                  <a:srgbClr val="94A3B8"/>
+                </a:solidFill>
+                <a:latin typeface="Inter"/>
+                <a:ea typeface="Inter"/>
+                <a:cs typeface="Inter"/>
+                <a:sym typeface="Inter"/>
+              </a:rPr>
+              <a:t>en</a:t>
+            </a:r>
+            <a:r>
+              <a:rPr lang="en-US" sz="1425" b="0" i="0" u="none" strike="noStrike" cap="none" dirty="0">
+                <a:solidFill>
+                  <a:srgbClr val="94A3B8"/>
+                </a:solidFill>
+                <a:latin typeface="Inter"/>
+                <a:ea typeface="Inter"/>
+                <a:cs typeface="Inter"/>
+                <a:sym typeface="Inter"/>
+              </a:rPr>
+              <a:t> </a:t>
+            </a:r>
+            <a:r>
+              <a:rPr lang="en-US" sz="1425" b="0" i="0" u="none" strike="noStrike" cap="none" dirty="0" err="1">
+                <a:solidFill>
+                  <a:srgbClr val="94A3B8"/>
+                </a:solidFill>
+                <a:latin typeface="Inter"/>
+                <a:ea typeface="Inter"/>
+                <a:cs typeface="Inter"/>
+                <a:sym typeface="Inter"/>
+              </a:rPr>
+              <a:t>el</a:t>
+            </a:r>
+            <a:r>
+              <a:rPr lang="en-US" sz="1425" b="0" i="0" u="none" strike="noStrike" cap="none" dirty="0">
+                <a:solidFill>
+                  <a:srgbClr val="94A3B8"/>
+                </a:solidFill>
+                <a:latin typeface="Inter"/>
+                <a:ea typeface="Inter"/>
+                <a:cs typeface="Inter"/>
+                <a:sym typeface="Inter"/>
+              </a:rPr>
+              <a:t> </a:t>
+            </a:r>
+            <a:r>
+              <a:rPr lang="en-US" sz="1425" b="0" i="0" u="none" strike="noStrike" cap="none" dirty="0" err="1">
+                <a:solidFill>
+                  <a:srgbClr val="94A3B8"/>
+                </a:solidFill>
+                <a:latin typeface="Inter"/>
+                <a:ea typeface="Inter"/>
+                <a:cs typeface="Inter"/>
+                <a:sym typeface="Inter"/>
+              </a:rPr>
+              <a:t>catálogo</a:t>
+            </a:r>
+            <a:r>
+              <a:rPr lang="en-US" sz="1425" b="0" i="0" u="none" strike="noStrike" cap="none" dirty="0">
+                <a:solidFill>
+                  <a:srgbClr val="94A3B8"/>
+                </a:solidFill>
+                <a:latin typeface="Inter"/>
+                <a:ea typeface="Inter"/>
+                <a:cs typeface="Inter"/>
+                <a:sym typeface="Inter"/>
+              </a:rPr>
+              <a:t> principal.</a:t>
+            </a:r>
+            <a:endParaRPr dirty="0"/>
+          </a:p>
+        </p:txBody>
+      </p:sp>
+    </p:spTree>
+  </p:cSld>
+  <p:clrMapOvr>
+    <a:masterClrMapping/>
+  </p:clrMapOvr>
+</p:sld>
+</file>
+
+<file path=ppt/slides/slide9.xml><?xml version="1.0" encoding="utf-8"?>
+<p:sld xmlns:a="http://schemas.openxmlformats.org/drawingml/2006/main" xmlns:r="http://schemas.openxmlformats.org/officeDocument/2006/relationships" xmlns:p="http://schemas.openxmlformats.org/presentationml/2006/main">
+  <p:cSld>
+    <p:bg>
+      <p:bgPr>
+        <a:solidFill>
           <a:srgbClr val="0B1120"/>
         </a:solidFill>
         <a:effectLst/>
@@ -20078,813 +20885,6 @@
                 <a:sym typeface="Inter"/>
               </a:rPr>
               <a:t>Aprovechar el campo codigo_local de los ejemplares para integrar un lector óptico, permitiendo automatizar el alta y devolución de préstamos mediante escaneo.</a:t>
-            </a:r>
-            <a:endParaRPr/>
-          </a:p>
-        </p:txBody>
-      </p:sp>
-    </p:spTree>
-  </p:cSld>
-  <p:clrMapOvr>
-    <a:masterClrMapping/>
-  </p:clrMapOvr>
-</p:sld>
-</file>
-
-<file path=ppt/slides/slide9.xml><?xml version="1.0" encoding="utf-8"?>
-<p:sld xmlns:a="http://schemas.openxmlformats.org/drawingml/2006/main" xmlns:r="http://schemas.openxmlformats.org/officeDocument/2006/relationships" xmlns:p="http://schemas.openxmlformats.org/presentationml/2006/main">
-  <p:cSld>
-    <p:bg>
-      <p:bgPr>
-        <a:solidFill>
-          <a:srgbClr val="0B1120"/>
-        </a:solidFill>
-        <a:effectLst/>
-      </p:bgPr>
-    </p:bg>
-    <p:spTree>
-      <p:nvGrpSpPr>
-        <p:cNvPr id="1" name="Shape 282"/>
-        <p:cNvGrpSpPr/>
-        <p:nvPr/>
-      </p:nvGrpSpPr>
-      <p:grpSpPr>
-        <a:xfrm>
-          <a:off x="0" y="0"/>
-          <a:ext cx="0" cy="0"/>
-          <a:chOff x="0" y="0"/>
-          <a:chExt cx="0" cy="0"/>
-        </a:xfrm>
-      </p:grpSpPr>
-      <p:pic>
-        <p:nvPicPr>
-          <p:cNvPr id="283" name="Google Shape;283;p22" descr="image.png"/>
-          <p:cNvPicPr preferRelativeResize="0"/>
-          <p:nvPr/>
-        </p:nvPicPr>
-        <p:blipFill rotWithShape="1">
-          <a:blip r:embed="rId3">
-            <a:alphaModFix/>
-          </a:blip>
-          <a:srcRect/>
-          <a:stretch/>
-        </p:blipFill>
-        <p:spPr>
-          <a:xfrm>
-            <a:off x="0" y="0"/>
-            <a:ext cx="12192000" cy="6858000"/>
-          </a:xfrm>
-          <a:prstGeom prst="rect">
-            <a:avLst/>
-          </a:prstGeom>
-          <a:noFill/>
-          <a:ln>
-            <a:noFill/>
-          </a:ln>
-        </p:spPr>
-      </p:pic>
-      <p:pic>
-        <p:nvPicPr>
-          <p:cNvPr id="285" name="Google Shape;285;p22" descr="image.png"/>
-          <p:cNvPicPr preferRelativeResize="0"/>
-          <p:nvPr/>
-        </p:nvPicPr>
-        <p:blipFill rotWithShape="1">
-          <a:blip r:embed="rId4">
-            <a:alphaModFix/>
-          </a:blip>
-          <a:srcRect/>
-          <a:stretch/>
-        </p:blipFill>
-        <p:spPr>
-          <a:xfrm>
-            <a:off x="6334125" y="2426940"/>
-            <a:ext cx="5276850" cy="2785020"/>
-          </a:xfrm>
-          <a:prstGeom prst="rect">
-            <a:avLst/>
-          </a:prstGeom>
-          <a:noFill/>
-          <a:ln>
-            <a:noFill/>
-          </a:ln>
-        </p:spPr>
-      </p:pic>
-      <p:pic>
-        <p:nvPicPr>
-          <p:cNvPr id="286" name="Google Shape;286;p22" descr="image.png"/>
-          <p:cNvPicPr preferRelativeResize="0"/>
-          <p:nvPr/>
-        </p:nvPicPr>
-        <p:blipFill rotWithShape="1">
-          <a:blip r:embed="rId5">
-            <a:alphaModFix/>
-          </a:blip>
-          <a:srcRect/>
-          <a:stretch/>
-        </p:blipFill>
-        <p:spPr>
-          <a:xfrm>
-            <a:off x="581025" y="6248400"/>
-            <a:ext cx="11029950" cy="314325"/>
-          </a:xfrm>
-          <a:prstGeom prst="rect">
-            <a:avLst/>
-          </a:prstGeom>
-          <a:noFill/>
-          <a:ln>
-            <a:noFill/>
-          </a:ln>
-        </p:spPr>
-      </p:pic>
-      <p:sp>
-        <p:nvSpPr>
-          <p:cNvPr id="287" name="Google Shape;287;p22"/>
-          <p:cNvSpPr txBox="1"/>
-          <p:nvPr/>
-        </p:nvSpPr>
-        <p:spPr>
-          <a:xfrm>
-            <a:off x="581025" y="6400800"/>
-            <a:ext cx="1495425" cy="161925"/>
-          </a:xfrm>
-          <a:prstGeom prst="rect">
-            <a:avLst/>
-          </a:prstGeom>
-          <a:noFill/>
-          <a:ln>
-            <a:noFill/>
-          </a:ln>
-        </p:spPr>
-        <p:txBody>
-          <a:bodyPr spcFirstLastPara="1" wrap="square" lIns="0" tIns="0" rIns="0" bIns="0" anchor="t" anchorCtr="0">
-            <a:spAutoFit/>
-          </a:bodyPr>
-          <a:lstStyle/>
-          <a:p>
-            <a:pPr marL="0" marR="0" lvl="0" indent="0" algn="l" rtl="0">
-              <a:spcBef>
-                <a:spcPts val="0"/>
-              </a:spcBef>
-              <a:spcAft>
-                <a:spcPts val="0"/>
-              </a:spcAft>
-              <a:buNone/>
-            </a:pPr>
-            <a:r>
-              <a:rPr lang="en-US" sz="1050" b="0" i="0" u="none" strike="noStrike" cap="none">
-                <a:solidFill>
-                  <a:srgbClr val="94A3B8"/>
-                </a:solidFill>
-                <a:latin typeface="Inter"/>
-                <a:ea typeface="Inter"/>
-                <a:cs typeface="Inter"/>
-                <a:sym typeface="Inter"/>
-              </a:rPr>
-              <a:t>LudiGest - Defensa TFG</a:t>
-            </a:r>
-            <a:endParaRPr/>
-          </a:p>
-        </p:txBody>
-      </p:sp>
-      <p:sp>
-        <p:nvSpPr>
-          <p:cNvPr id="288" name="Google Shape;288;p22"/>
-          <p:cNvSpPr txBox="1"/>
-          <p:nvPr/>
-        </p:nvSpPr>
-        <p:spPr>
-          <a:xfrm>
-            <a:off x="10239375" y="6400800"/>
-            <a:ext cx="1371600" cy="161925"/>
-          </a:xfrm>
-          <a:prstGeom prst="rect">
-            <a:avLst/>
-          </a:prstGeom>
-          <a:noFill/>
-          <a:ln>
-            <a:noFill/>
-          </a:ln>
-        </p:spPr>
-        <p:txBody>
-          <a:bodyPr spcFirstLastPara="1" wrap="square" lIns="0" tIns="0" rIns="0" bIns="0" anchor="t" anchorCtr="0">
-            <a:spAutoFit/>
-          </a:bodyPr>
-          <a:lstStyle/>
-          <a:p>
-            <a:pPr marL="0" marR="0" lvl="0" indent="0" algn="l" rtl="0">
-              <a:spcBef>
-                <a:spcPts val="0"/>
-              </a:spcBef>
-              <a:spcAft>
-                <a:spcPts val="0"/>
-              </a:spcAft>
-              <a:buNone/>
-            </a:pPr>
-            <a:r>
-              <a:rPr lang="en-US" sz="1050" b="0" i="0" u="none" strike="noStrike" cap="none">
-                <a:solidFill>
-                  <a:srgbClr val="94A3B8"/>
-                </a:solidFill>
-                <a:latin typeface="Inter"/>
-                <a:ea typeface="Inter"/>
-                <a:cs typeface="Inter"/>
-                <a:sym typeface="Inter"/>
-              </a:rPr>
-              <a:t>Fin de la Presentación</a:t>
-            </a:r>
-            <a:endParaRPr/>
-          </a:p>
-        </p:txBody>
-      </p:sp>
-      <p:pic>
-        <p:nvPicPr>
-          <p:cNvPr id="289" name="Google Shape;289;p22" descr="image.png"/>
-          <p:cNvPicPr preferRelativeResize="0"/>
-          <p:nvPr/>
-        </p:nvPicPr>
-        <p:blipFill rotWithShape="1">
-          <a:blip r:embed="rId6">
-            <a:alphaModFix/>
-          </a:blip>
-          <a:srcRect/>
-          <a:stretch/>
-        </p:blipFill>
-        <p:spPr>
-          <a:xfrm>
-            <a:off x="8615362" y="2817465"/>
-            <a:ext cx="714375" cy="571500"/>
-          </a:xfrm>
-          <a:prstGeom prst="rect">
-            <a:avLst/>
-          </a:prstGeom>
-          <a:noFill/>
-          <a:ln>
-            <a:noFill/>
-          </a:ln>
-        </p:spPr>
-      </p:pic>
-      <p:pic>
-        <p:nvPicPr>
-          <p:cNvPr id="290" name="Google Shape;290;p22" descr="image.png"/>
-          <p:cNvPicPr preferRelativeResize="0"/>
-          <p:nvPr/>
-        </p:nvPicPr>
-        <p:blipFill rotWithShape="1">
-          <a:blip r:embed="rId7">
-            <a:alphaModFix/>
-          </a:blip>
-          <a:srcRect/>
-          <a:stretch/>
-        </p:blipFill>
-        <p:spPr>
-          <a:xfrm>
-            <a:off x="581025" y="3425279"/>
-            <a:ext cx="171450" cy="200025"/>
-          </a:xfrm>
-          <a:prstGeom prst="rect">
-            <a:avLst/>
-          </a:prstGeom>
-          <a:noFill/>
-          <a:ln>
-            <a:noFill/>
-          </a:ln>
-        </p:spPr>
-      </p:pic>
-      <p:pic>
-        <p:nvPicPr>
-          <p:cNvPr id="291" name="Google Shape;291;p22" descr="image.png"/>
-          <p:cNvPicPr preferRelativeResize="0"/>
-          <p:nvPr/>
-        </p:nvPicPr>
-        <p:blipFill rotWithShape="1">
-          <a:blip r:embed="rId7">
-            <a:alphaModFix/>
-          </a:blip>
-          <a:srcRect/>
-          <a:stretch/>
-        </p:blipFill>
-        <p:spPr>
-          <a:xfrm>
-            <a:off x="581025" y="4147095"/>
-            <a:ext cx="171450" cy="200025"/>
-          </a:xfrm>
-          <a:prstGeom prst="rect">
-            <a:avLst/>
-          </a:prstGeom>
-          <a:noFill/>
-          <a:ln>
-            <a:noFill/>
-          </a:ln>
-        </p:spPr>
-      </p:pic>
-      <p:pic>
-        <p:nvPicPr>
-          <p:cNvPr id="292" name="Google Shape;292;p22" descr="image.png"/>
-          <p:cNvPicPr preferRelativeResize="0"/>
-          <p:nvPr/>
-        </p:nvPicPr>
-        <p:blipFill rotWithShape="1">
-          <a:blip r:embed="rId7">
-            <a:alphaModFix/>
-          </a:blip>
-          <a:srcRect/>
-          <a:stretch/>
-        </p:blipFill>
-        <p:spPr>
-          <a:xfrm>
-            <a:off x="581025" y="4868912"/>
-            <a:ext cx="171450" cy="200025"/>
-          </a:xfrm>
-          <a:prstGeom prst="rect">
-            <a:avLst/>
-          </a:prstGeom>
-          <a:noFill/>
-          <a:ln>
-            <a:noFill/>
-          </a:ln>
-        </p:spPr>
-      </p:pic>
-      <p:sp>
-        <p:nvSpPr>
-          <p:cNvPr id="293" name="Google Shape;293;p22"/>
-          <p:cNvSpPr txBox="1"/>
-          <p:nvPr/>
-        </p:nvSpPr>
-        <p:spPr>
-          <a:xfrm>
-            <a:off x="771525" y="485775"/>
-            <a:ext cx="11381422" cy="542925"/>
-          </a:xfrm>
-          <a:prstGeom prst="rect">
-            <a:avLst/>
-          </a:prstGeom>
-          <a:noFill/>
-          <a:ln>
-            <a:noFill/>
-          </a:ln>
-        </p:spPr>
-        <p:txBody>
-          <a:bodyPr spcFirstLastPara="1" wrap="square" lIns="0" tIns="0" rIns="0" bIns="0" anchor="t" anchorCtr="0">
-            <a:spAutoFit/>
-          </a:bodyPr>
-          <a:lstStyle/>
-          <a:p>
-            <a:pPr marL="0" marR="0" lvl="0" indent="0" algn="l" rtl="0">
-              <a:spcBef>
-                <a:spcPts val="0"/>
-              </a:spcBef>
-              <a:spcAft>
-                <a:spcPts val="0"/>
-              </a:spcAft>
-              <a:buNone/>
-            </a:pPr>
-            <a:r>
-              <a:rPr lang="en-US" sz="2850" b="1" i="0" u="none" strike="noStrike" cap="none">
-                <a:solidFill>
-                  <a:srgbClr val="F8FAFC"/>
-                </a:solidFill>
-                <a:latin typeface="Poppins"/>
-                <a:ea typeface="Poppins"/>
-                <a:cs typeface="Poppins"/>
-                <a:sym typeface="Poppins"/>
-              </a:rPr>
-              <a:t>9. Conclusiones Personales</a:t>
-            </a:r>
-            <a:endParaRPr/>
-          </a:p>
-        </p:txBody>
-      </p:sp>
-      <p:sp>
-        <p:nvSpPr>
-          <p:cNvPr id="294" name="Google Shape;294;p22"/>
-          <p:cNvSpPr/>
-          <p:nvPr/>
-        </p:nvSpPr>
-        <p:spPr>
-          <a:xfrm>
-            <a:off x="581025" y="485775"/>
-            <a:ext cx="57150" cy="542925"/>
-          </a:xfrm>
-          <a:prstGeom prst="rect">
-            <a:avLst/>
-          </a:prstGeom>
-          <a:solidFill>
-            <a:srgbClr val="0EA5E9"/>
-          </a:solidFill>
-          <a:ln>
-            <a:noFill/>
-          </a:ln>
-        </p:spPr>
-        <p:txBody>
-          <a:bodyPr spcFirstLastPara="1" wrap="square" lIns="91425" tIns="45700" rIns="91425" bIns="45700" anchor="ctr" anchorCtr="0">
-            <a:noAutofit/>
-          </a:bodyPr>
-          <a:lstStyle/>
-          <a:p>
-            <a:pPr marL="0" marR="0" lvl="0" indent="0" algn="ctr" rtl="0">
-              <a:spcBef>
-                <a:spcPts val="0"/>
-              </a:spcBef>
-              <a:spcAft>
-                <a:spcPts val="0"/>
-              </a:spcAft>
-              <a:buNone/>
-            </a:pPr>
-            <a:endParaRPr sz="1800" b="0" i="0" u="none" strike="noStrike" cap="none">
-              <a:solidFill>
-                <a:schemeClr val="dk1"/>
-              </a:solidFill>
-              <a:latin typeface="Calibri"/>
-              <a:ea typeface="Calibri"/>
-              <a:cs typeface="Calibri"/>
-              <a:sym typeface="Calibri"/>
-            </a:endParaRPr>
-          </a:p>
-        </p:txBody>
-      </p:sp>
-      <p:sp>
-        <p:nvSpPr>
-          <p:cNvPr id="295" name="Google Shape;295;p22"/>
-          <p:cNvSpPr txBox="1"/>
-          <p:nvPr/>
-        </p:nvSpPr>
-        <p:spPr>
-          <a:xfrm>
-            <a:off x="581025" y="2091183"/>
-            <a:ext cx="5276850" cy="1005482"/>
-          </a:xfrm>
-          <a:prstGeom prst="rect">
-            <a:avLst/>
-          </a:prstGeom>
-          <a:noFill/>
-          <a:ln>
-            <a:noFill/>
-          </a:ln>
-        </p:spPr>
-        <p:txBody>
-          <a:bodyPr spcFirstLastPara="1" wrap="square" lIns="0" tIns="0" rIns="0" bIns="0" anchor="t" anchorCtr="0">
-            <a:spAutoFit/>
-          </a:bodyPr>
-          <a:lstStyle/>
-          <a:p>
-            <a:pPr marL="0" marR="0" lvl="0" indent="0" algn="l" rtl="0">
-              <a:lnSpc>
-                <a:spcPct val="160000"/>
-              </a:lnSpc>
-              <a:spcBef>
-                <a:spcPts val="0"/>
-              </a:spcBef>
-              <a:spcAft>
-                <a:spcPts val="0"/>
-              </a:spcAft>
-              <a:buNone/>
-            </a:pPr>
-            <a:r>
-              <a:rPr lang="en-US" sz="1650" b="0" i="0" u="none" strike="noStrike" cap="none">
-                <a:solidFill>
-                  <a:srgbClr val="94A3B8"/>
-                </a:solidFill>
-                <a:latin typeface="Inter"/>
-                <a:ea typeface="Inter"/>
-                <a:cs typeface="Inter"/>
-                <a:sym typeface="Inter"/>
-              </a:rPr>
-              <a:t>Este Trabajo de Fin de Grado me ha permitido enfrentarme al ciclo de vida completo de un software profesional:</a:t>
-            </a:r>
-            <a:endParaRPr/>
-          </a:p>
-        </p:txBody>
-      </p:sp>
-      <p:sp>
-        <p:nvSpPr>
-          <p:cNvPr id="296" name="Google Shape;296;p22"/>
-          <p:cNvSpPr txBox="1"/>
-          <p:nvPr/>
-        </p:nvSpPr>
-        <p:spPr>
-          <a:xfrm>
-            <a:off x="6612255" y="3579465"/>
-            <a:ext cx="4720590" cy="276225"/>
-          </a:xfrm>
-          <a:prstGeom prst="rect">
-            <a:avLst/>
-          </a:prstGeom>
-          <a:noFill/>
-          <a:ln>
-            <a:noFill/>
-          </a:ln>
-        </p:spPr>
-        <p:txBody>
-          <a:bodyPr spcFirstLastPara="1" wrap="square" lIns="0" tIns="0" rIns="0" bIns="0" anchor="t" anchorCtr="0">
-            <a:spAutoFit/>
-          </a:bodyPr>
-          <a:lstStyle/>
-          <a:p>
-            <a:pPr marL="0" marR="0" lvl="0" indent="0" algn="ctr" rtl="0">
-              <a:spcBef>
-                <a:spcPts val="0"/>
-              </a:spcBef>
-              <a:spcAft>
-                <a:spcPts val="0"/>
-              </a:spcAft>
-              <a:buNone/>
-            </a:pPr>
-            <a:r>
-              <a:rPr lang="en-US" sz="1404" b="1" i="0" u="none" strike="noStrike" cap="none">
-                <a:solidFill>
-                  <a:srgbClr val="F8FAFC"/>
-                </a:solidFill>
-                <a:latin typeface="Poppins"/>
-                <a:ea typeface="Poppins"/>
-                <a:cs typeface="Poppins"/>
-                <a:sym typeface="Poppins"/>
-              </a:rPr>
-              <a:t>Objetivo Cumplido</a:t>
-            </a:r>
-            <a:endParaRPr/>
-          </a:p>
-        </p:txBody>
-      </p:sp>
-      <p:sp>
-        <p:nvSpPr>
-          <p:cNvPr id="297" name="Google Shape;297;p22"/>
-          <p:cNvSpPr txBox="1"/>
-          <p:nvPr/>
-        </p:nvSpPr>
-        <p:spPr>
-          <a:xfrm>
-            <a:off x="6724650" y="3998565"/>
-            <a:ext cx="4495800" cy="822870"/>
-          </a:xfrm>
-          <a:prstGeom prst="rect">
-            <a:avLst/>
-          </a:prstGeom>
-          <a:noFill/>
-          <a:ln>
-            <a:noFill/>
-          </a:ln>
-        </p:spPr>
-        <p:txBody>
-          <a:bodyPr spcFirstLastPara="1" wrap="square" lIns="0" tIns="0" rIns="0" bIns="0" anchor="t" anchorCtr="0">
-            <a:spAutoFit/>
-          </a:bodyPr>
-          <a:lstStyle/>
-          <a:p>
-            <a:pPr marL="0" marR="0" lvl="0" indent="0" algn="ctr" rtl="0">
-              <a:lnSpc>
-                <a:spcPct val="160000"/>
-              </a:lnSpc>
-              <a:spcBef>
-                <a:spcPts val="0"/>
-              </a:spcBef>
-              <a:spcAft>
-                <a:spcPts val="0"/>
-              </a:spcAft>
-              <a:buNone/>
-            </a:pPr>
-            <a:r>
-              <a:rPr lang="en-US" sz="1350" b="0" i="0" u="none" strike="noStrike" cap="none">
-                <a:solidFill>
-                  <a:srgbClr val="94A3B8"/>
-                </a:solidFill>
-                <a:latin typeface="Inter"/>
-                <a:ea typeface="Inter"/>
-                <a:cs typeface="Inter"/>
-                <a:sym typeface="Inter"/>
-              </a:rPr>
-              <a:t>LudiGest no es solo un proyecto académico; es una solución real y funcional lista para ser desplegada en producción.</a:t>
-            </a:r>
-            <a:endParaRPr/>
-          </a:p>
-        </p:txBody>
-      </p:sp>
-      <p:sp>
-        <p:nvSpPr>
-          <p:cNvPr id="298" name="Google Shape;298;p22"/>
-          <p:cNvSpPr txBox="1"/>
-          <p:nvPr/>
-        </p:nvSpPr>
-        <p:spPr>
-          <a:xfrm>
-            <a:off x="962025" y="3382416"/>
-            <a:ext cx="4895850" cy="578941"/>
-          </a:xfrm>
-          <a:prstGeom prst="rect">
-            <a:avLst/>
-          </a:prstGeom>
-          <a:noFill/>
-          <a:ln>
-            <a:noFill/>
-          </a:ln>
-        </p:spPr>
-        <p:txBody>
-          <a:bodyPr spcFirstLastPara="1" wrap="square" lIns="0" tIns="0" rIns="0" bIns="0" anchor="t" anchorCtr="0">
-            <a:spAutoFit/>
-          </a:bodyPr>
-          <a:lstStyle/>
-          <a:p>
-            <a:pPr marL="0" marR="0" lvl="0" indent="0" algn="l" rtl="0">
-              <a:lnSpc>
-                <a:spcPct val="159929"/>
-              </a:lnSpc>
-              <a:spcBef>
-                <a:spcPts val="0"/>
-              </a:spcBef>
-              <a:spcAft>
-                <a:spcPts val="0"/>
-              </a:spcAft>
-              <a:buNone/>
-            </a:pPr>
-            <a:r>
-              <a:rPr lang="en-US" sz="1425" b="0" i="0" u="none" strike="noStrike" cap="none">
-                <a:solidFill>
-                  <a:srgbClr val="94A3B8"/>
-                </a:solidFill>
-                <a:latin typeface="Inter"/>
-                <a:ea typeface="Inter"/>
-                <a:cs typeface="Inter"/>
-                <a:sym typeface="Inter"/>
-              </a:rPr>
-              <a:t>Comprensión profunda de la </a:t>
-            </a:r>
-            <a:r>
-              <a:rPr lang="en-US" sz="1425" b="0" i="0" u="none" strike="noStrike" cap="none">
-                <a:solidFill>
-                  <a:srgbClr val="F8FAFC"/>
-                </a:solidFill>
-                <a:latin typeface="Inter SemiBold"/>
-                <a:ea typeface="Inter SemiBold"/>
-                <a:cs typeface="Inter SemiBold"/>
-                <a:sym typeface="Inter SemiBold"/>
-              </a:rPr>
-              <a:t>arquitectura y patrones de diseño</a:t>
-            </a:r>
-            <a:r>
-              <a:rPr lang="en-US" sz="1425" b="0" i="0" u="none" strike="noStrike" cap="none">
-                <a:solidFill>
-                  <a:srgbClr val="94A3B8"/>
-                </a:solidFill>
-                <a:latin typeface="Inter"/>
-                <a:ea typeface="Inter"/>
-                <a:cs typeface="Inter"/>
-                <a:sym typeface="Inter"/>
-              </a:rPr>
-              <a:t> (MVC, REST, DTOs).</a:t>
-            </a:r>
-            <a:endParaRPr/>
-          </a:p>
-        </p:txBody>
-      </p:sp>
-      <p:sp>
-        <p:nvSpPr>
-          <p:cNvPr id="299" name="Google Shape;299;p22"/>
-          <p:cNvSpPr txBox="1"/>
-          <p:nvPr/>
-        </p:nvSpPr>
-        <p:spPr>
-          <a:xfrm>
-            <a:off x="962025" y="4104233"/>
-            <a:ext cx="4895850" cy="578941"/>
-          </a:xfrm>
-          <a:prstGeom prst="rect">
-            <a:avLst/>
-          </a:prstGeom>
-          <a:noFill/>
-          <a:ln>
-            <a:noFill/>
-          </a:ln>
-        </p:spPr>
-        <p:txBody>
-          <a:bodyPr spcFirstLastPara="1" wrap="square" lIns="0" tIns="0" rIns="0" bIns="0" anchor="t" anchorCtr="0">
-            <a:spAutoFit/>
-          </a:bodyPr>
-          <a:lstStyle/>
-          <a:p>
-            <a:pPr marL="0" marR="0" lvl="0" indent="0" algn="l" rtl="0">
-              <a:lnSpc>
-                <a:spcPct val="159929"/>
-              </a:lnSpc>
-              <a:spcBef>
-                <a:spcPts val="0"/>
-              </a:spcBef>
-              <a:spcAft>
-                <a:spcPts val="0"/>
-              </a:spcAft>
-              <a:buNone/>
-            </a:pPr>
-            <a:r>
-              <a:rPr lang="en-US" sz="1425" b="0" i="0" u="none" strike="noStrike" cap="none">
-                <a:solidFill>
-                  <a:srgbClr val="94A3B8"/>
-                </a:solidFill>
-                <a:latin typeface="Inter"/>
-                <a:ea typeface="Inter"/>
-                <a:cs typeface="Inter"/>
-                <a:sym typeface="Inter"/>
-              </a:rPr>
-              <a:t>Manejo real de </a:t>
-            </a:r>
-            <a:r>
-              <a:rPr lang="en-US" sz="1425" b="0" i="0" u="none" strike="noStrike" cap="none">
-                <a:solidFill>
-                  <a:srgbClr val="F8FAFC"/>
-                </a:solidFill>
-                <a:latin typeface="Inter SemiBold"/>
-                <a:ea typeface="Inter SemiBold"/>
-                <a:cs typeface="Inter SemiBold"/>
-                <a:sym typeface="Inter SemiBold"/>
-              </a:rPr>
-              <a:t>concurrencia y bases de datos</a:t>
-            </a:r>
-            <a:r>
-              <a:rPr lang="en-US" sz="1425" b="0" i="0" u="none" strike="noStrike" cap="none">
-                <a:solidFill>
-                  <a:srgbClr val="94A3B8"/>
-                </a:solidFill>
-                <a:latin typeface="Inter"/>
-                <a:ea typeface="Inter"/>
-                <a:cs typeface="Inter"/>
-                <a:sym typeface="Inter"/>
-              </a:rPr>
-              <a:t> transaccionales.</a:t>
-            </a:r>
-            <a:endParaRPr/>
-          </a:p>
-        </p:txBody>
-      </p:sp>
-      <p:sp>
-        <p:nvSpPr>
-          <p:cNvPr id="300" name="Google Shape;300;p22"/>
-          <p:cNvSpPr txBox="1"/>
-          <p:nvPr/>
-        </p:nvSpPr>
-        <p:spPr>
-          <a:xfrm>
-            <a:off x="962025" y="4826049"/>
-            <a:ext cx="4895850" cy="578941"/>
-          </a:xfrm>
-          <a:prstGeom prst="rect">
-            <a:avLst/>
-          </a:prstGeom>
-          <a:noFill/>
-          <a:ln>
-            <a:noFill/>
-          </a:ln>
-        </p:spPr>
-        <p:txBody>
-          <a:bodyPr spcFirstLastPara="1" wrap="square" lIns="0" tIns="0" rIns="0" bIns="0" anchor="t" anchorCtr="0">
-            <a:spAutoFit/>
-          </a:bodyPr>
-          <a:lstStyle/>
-          <a:p>
-            <a:pPr marL="0" marR="0" lvl="0" indent="0" algn="l" rtl="0">
-              <a:lnSpc>
-                <a:spcPct val="159929"/>
-              </a:lnSpc>
-              <a:spcBef>
-                <a:spcPts val="0"/>
-              </a:spcBef>
-              <a:spcAft>
-                <a:spcPts val="0"/>
-              </a:spcAft>
-              <a:buNone/>
-            </a:pPr>
-            <a:r>
-              <a:rPr lang="en-US" sz="1425" b="0" i="0" u="none" strike="noStrike" cap="none">
-                <a:solidFill>
-                  <a:srgbClr val="94A3B8"/>
-                </a:solidFill>
-                <a:latin typeface="Inter"/>
-                <a:ea typeface="Inter"/>
-                <a:cs typeface="Inter"/>
-                <a:sym typeface="Inter"/>
-              </a:rPr>
-              <a:t>Valor de escribir </a:t>
-            </a:r>
-            <a:r>
-              <a:rPr lang="en-US" sz="1425" b="0" i="0" u="none" strike="noStrike" cap="none">
-                <a:solidFill>
-                  <a:srgbClr val="F8FAFC"/>
-                </a:solidFill>
-                <a:latin typeface="Inter SemiBold"/>
-                <a:ea typeface="Inter SemiBold"/>
-                <a:cs typeface="Inter SemiBold"/>
-                <a:sym typeface="Inter SemiBold"/>
-              </a:rPr>
-              <a:t>código limpio, escalable</a:t>
-            </a:r>
-            <a:r>
-              <a:rPr lang="en-US" sz="1425" b="0" i="0" u="none" strike="noStrike" cap="none">
-                <a:solidFill>
-                  <a:srgbClr val="94A3B8"/>
-                </a:solidFill>
-                <a:latin typeface="Inter"/>
-                <a:ea typeface="Inter"/>
-                <a:cs typeface="Inter"/>
-                <a:sym typeface="Inter"/>
-              </a:rPr>
-              <a:t> y protegido contra fallos externos (APIs).</a:t>
             </a:r>
             <a:endParaRPr/>
           </a:p>

</xml_diff>